<commit_message>
Add landing A/B variants (Providores + distributor voice) and A/B button
</commit_message>
<xml_diff>
--- a/Agripals-Investor-Deck.pptx
+++ b/Agripals-Investor-Deck.pptx
@@ -12,6 +12,7 @@
     <p:sldId id="260" r:id="rId6"/>
     <p:sldId id="261" r:id="rId7"/>
     <p:sldId id="262" r:id="rId8"/>
+    <p:sldId id="272" r:id="rId23"/>
     <p:sldId id="263" r:id="rId9"/>
     <p:sldId id="264" r:id="rId10"/>
     <p:sldId id="270" r:id="rId21"/>
@@ -2053,6 +2054,10 @@
           </a:solidFill>
           <a:ln/>
         </p:spPr>
+        <p:txBody>
+          <a:bodyPr/>
+          <a:p/>
+        </p:txBody>
       </p:sp>
       <p:sp>
         <p:nvSpPr>
@@ -2087,7 +2092,7 @@
                 <a:ea typeface="Calibri" pitchFamily="34" charset="-122"/>
                 <a:cs typeface="Calibri" pitchFamily="34" charset="-120"/>
               </a:rPr>
-              <a:t>✦ BLEEDING-EDGE AI × AGRICULTURE</a:t>
+              <a:t>✦ ONLINE-ONLY · AI-NATIVE FOOD WHOLESALER</a:t>
             </a:r>
             <a:endParaRPr lang="en-US" sz="1300" dirty="0"/>
           </a:p>
@@ -2191,7 +2196,7 @@
                 <a:ea typeface="Calibri" pitchFamily="34" charset="-122"/>
                 <a:cs typeface="Calibri" pitchFamily="34" charset="-120"/>
               </a:rPr>
-              <a:t>Agripals connects restaurants directly with the farms that grow, catch and grade their food — cutting the markup, restoring provenance, and rebuilding the route from farm to plate.</a:t>
+              <a:t>An online-only, AI-native food wholesaler. Agripals connects restaurants directly with the farms that grow, catch and grade their food — all over text — cutting the markup and rebuilding the route from farm to plate.</a:t>
             </a:r>
             <a:endParaRPr lang="en-US" sz="1650" dirty="0"/>
           </a:p>
@@ -2325,7 +2330,7 @@
                 <a:ea typeface="Calibri" pitchFamily="34" charset="-122"/>
                 <a:cs typeface="Calibri" pitchFamily="34" charset="-120"/>
               </a:rPr>
-              <a:t>BUSINESS MODEL</a:t>
+              <a:t>GO TO MARKET</a:t>
             </a:r>
             <a:endParaRPr lang="en-US" sz="1250" dirty="0"/>
           </a:p>
@@ -2367,7 +2372,7 @@
                 <a:ea typeface="Calibri" pitchFamily="34" charset="-122"/>
                 <a:cs typeface="Calibri" pitchFamily="34" charset="-120"/>
               </a:rPr>
-              <a:t>We earn when food moves: 5% of every order.</a:t>
+              <a:t>One city. One product. One clear proof point.</a:t>
             </a:r>
             <a:endParaRPr lang="en-US" sz="3400" dirty="0"/>
           </a:p>
@@ -2409,7 +2414,7 @@
                 <a:ea typeface="Calibri" pitchFamily="34" charset="-122"/>
                 <a:cs typeface="Calibri" pitchFamily="34" charset="-120"/>
               </a:rPr>
-              <a:t>Simple, aligned economics. Agripals takes a small cut of everything it moves — and the cheaper it makes food, the more that moves.</a:t>
+              <a:t>San Francisco oysters — direct from Northern California farms into SF restaurants — then expand the same rails outward.</a:t>
             </a:r>
             <a:endParaRPr lang="en-US" sz="1600" dirty="0"/>
           </a:p>
@@ -2544,7 +2549,7 @@
                 <a:ea typeface="Calibri" pitchFamily="34" charset="-122"/>
                 <a:cs typeface="Calibri" pitchFamily="34" charset="-120"/>
               </a:rPr>
-              <a:t>Take rate</a:t>
+              <a:t>Phase 1</a:t>
             </a:r>
             <a:endParaRPr lang="en-US" sz="1100" dirty="0"/>
           </a:p>
@@ -2583,7 +2588,7 @@
                 <a:ea typeface="Calibri" pitchFamily="34" charset="-122"/>
                 <a:cs typeface="Calibri" pitchFamily="34" charset="-120"/>
               </a:rPr>
-              <a:t>5% of every order</a:t>
+              <a:t>SF oysters</a:t>
             </a:r>
             <a:endParaRPr lang="en-US" sz="1550" dirty="0"/>
           </a:p>
@@ -2625,7 +2630,7 @@
                 <a:ea typeface="Calibri" pitchFamily="34" charset="-122"/>
                 <a:cs typeface="Calibri" pitchFamily="34" charset="-120"/>
               </a:rPr>
-              <a:t>Agripals takes ~5% of each order's value (GMV). No subscription — we only earn when the kitchen saves.</a:t>
+              <a:t>~10 oyster farmers, 10–20 restaurants, one reliable cold-chain logistics partner.</a:t>
             </a:r>
             <a:endParaRPr lang="en-US" sz="1280" dirty="0"/>
           </a:p>
@@ -2760,7 +2765,7 @@
                 <a:ea typeface="Calibri" pitchFamily="34" charset="-122"/>
                 <a:cs typeface="Calibri" pitchFamily="34" charset="-120"/>
               </a:rPr>
-              <a:t>Credit float</a:t>
+              <a:t>Phase 2</a:t>
             </a:r>
             <a:endParaRPr lang="en-US" sz="1100" dirty="0"/>
           </a:p>
@@ -2799,7 +2804,7 @@
                 <a:ea typeface="Calibri" pitchFamily="34" charset="-122"/>
                 <a:cs typeface="Calibri" pitchFamily="34" charset="-120"/>
               </a:rPr>
-              <a:t>We finance the middle</a:t>
+              <a:t>More direct seafood</a:t>
             </a:r>
             <a:endParaRPr lang="en-US" sz="1550" dirty="0"/>
           </a:p>
@@ -2841,7 +2846,7 @@
                 <a:ea typeface="Calibri" pitchFamily="34" charset="-122"/>
                 <a:cs typeface="Calibri" pitchFamily="34" charset="-120"/>
               </a:rPr>
-              <a:t>Farms don't want to carry credit. We pay them on delivery and bill kitchens on terms — earning a financing margin.</a:t>
+              <a:t>Shrimp, lobster, crab and other gradable products where freshness and provenance matter.</a:t>
             </a:r>
             <a:endParaRPr lang="en-US" sz="1280" dirty="0"/>
           </a:p>
@@ -2976,7 +2981,7 @@
                 <a:ea typeface="Calibri" pitchFamily="34" charset="-122"/>
                 <a:cs typeface="Calibri" pitchFamily="34" charset="-120"/>
               </a:rPr>
-              <a:t>Network data</a:t>
+              <a:t>Phase 3</a:t>
             </a:r>
             <a:endParaRPr lang="en-US" sz="1100" dirty="0"/>
           </a:p>
@@ -3015,7 +3020,7 @@
                 <a:ea typeface="Calibri" pitchFamily="34" charset="-122"/>
                 <a:cs typeface="Calibri" pitchFamily="34" charset="-120"/>
               </a:rPr>
-              <a:t>It compounds</a:t>
+              <a:t>Direct import / export</a:t>
             </a:r>
             <a:endParaRPr lang="en-US" sz="1550" dirty="0"/>
           </a:p>
@@ -3057,7 +3062,7 @@
                 <a:ea typeface="Calibri" pitchFamily="34" charset="-122"/>
                 <a:cs typeface="Calibri" pitchFamily="34" charset="-120"/>
               </a:rPr>
-              <a:t>Every order sharpens pricing, grading and demand — better matches over time, and a moat that widens with volume.</a:t>
+              <a:t>Cut exporters and importers too, with AI coordinating documents, routing and compliance.</a:t>
             </a:r>
             <a:endParaRPr lang="en-US" sz="1280" dirty="0"/>
           </a:p>
@@ -3150,6 +3155,887 @@
 </file>
 
 <file path=ppt/slides/slide11.xml><?xml version="1.0" encoding="utf-8"?>
+<p:sld xmlns:a="http://schemas.openxmlformats.org/drawingml/2006/main" xmlns:r="http://schemas.openxmlformats.org/officeDocument/2006/relationships" xmlns:p="http://schemas.openxmlformats.org/presentationml/2006/main">
+  <p:cSld name="Slide 9">
+    <p:bg>
+      <p:bgPr>
+        <a:solidFill>
+          <a:srgbClr val="F4F7F6"/>
+        </a:solidFill>
+      </p:bgPr>
+    </p:bg>
+    <p:spTree>
+      <p:nvGrpSpPr>
+        <p:cNvPr id="1" name=""/>
+        <p:cNvGrpSpPr/>
+        <p:nvPr/>
+      </p:nvGrpSpPr>
+      <p:grpSpPr>
+        <a:xfrm>
+          <a:off x="0" y="0"/>
+          <a:ext cx="0" cy="0"/>
+          <a:chOff x="0" y="0"/>
+          <a:chExt cx="0" cy="0"/>
+        </a:xfrm>
+      </p:grpSpPr>
+      <p:sp>
+        <p:nvSpPr>
+          <p:cNvPr id="2" name="Text 0"/>
+          <p:cNvSpPr/>
+          <p:nvPr/>
+        </p:nvSpPr>
+        <p:spPr>
+          <a:xfrm>
+            <a:off x="658368" y="457200"/>
+            <a:ext cx="8229600" cy="320040"/>
+          </a:xfrm>
+          <a:prstGeom prst="rect">
+            <a:avLst/>
+          </a:prstGeom>
+          <a:noFill/>
+          <a:ln/>
+        </p:spPr>
+        <p:txBody>
+          <a:bodyPr wrap="square" lIns="0" tIns="0" rIns="0" bIns="0" rtlCol="0" anchor="ctr"/>
+          <a:lstStyle/>
+          <a:p>
+            <a:pPr algn="l" indent="0" marL="0">
+              <a:buNone/>
+            </a:pPr>
+            <a:r>
+              <a:rPr lang="en-US" sz="1250" b="1" spc="300" kern="0" dirty="0">
+                <a:solidFill>
+                  <a:srgbClr val="37A278"/>
+                </a:solidFill>
+                <a:latin typeface="Calibri" pitchFamily="34" charset="0"/>
+                <a:ea typeface="Calibri" pitchFamily="34" charset="-122"/>
+                <a:cs typeface="Calibri" pitchFamily="34" charset="-120"/>
+              </a:rPr>
+              <a:t>BUSINESS MODEL</a:t>
+            </a:r>
+            <a:endParaRPr lang="en-US" sz="1250" dirty="0"/>
+          </a:p>
+        </p:txBody>
+      </p:sp>
+      <p:sp>
+        <p:nvSpPr>
+          <p:cNvPr id="3" name="Text 1"/>
+          <p:cNvSpPr/>
+          <p:nvPr/>
+        </p:nvSpPr>
+        <p:spPr>
+          <a:xfrm>
+            <a:off x="658368" y="841248"/>
+            <a:ext cx="10872216" cy="1051560"/>
+          </a:xfrm>
+          <a:prstGeom prst="rect">
+            <a:avLst/>
+          </a:prstGeom>
+          <a:noFill/>
+          <a:ln/>
+        </p:spPr>
+        <p:txBody>
+          <a:bodyPr wrap="square" lIns="0" tIns="0" rIns="0" bIns="0" rtlCol="0" anchor="ctr"/>
+          <a:lstStyle/>
+          <a:p>
+            <a:pPr algn="l" indent="0" marL="0">
+              <a:lnSpc>
+                <a:spcPct val="100000"/>
+              </a:lnSpc>
+              <a:buNone/>
+            </a:pPr>
+            <a:r>
+              <a:rPr lang="en-US" sz="3400" b="1" dirty="0">
+                <a:solidFill>
+                  <a:srgbClr val="123024"/>
+                </a:solidFill>
+                <a:latin typeface="Calibri" pitchFamily="34" charset="0"/>
+                <a:ea typeface="Calibri" pitchFamily="34" charset="-122"/>
+                <a:cs typeface="Calibri" pitchFamily="34" charset="-120"/>
+              </a:rPr>
+              <a:t>We earn when food moves: 5% of every order.</a:t>
+            </a:r>
+            <a:endParaRPr lang="en-US" sz="3400" dirty="0"/>
+          </a:p>
+        </p:txBody>
+      </p:sp>
+      <p:sp>
+        <p:nvSpPr>
+          <p:cNvPr id="4" name="Text 2"/>
+          <p:cNvSpPr/>
+          <p:nvPr/>
+        </p:nvSpPr>
+        <p:spPr>
+          <a:xfrm>
+            <a:off x="658368" y="1828800"/>
+            <a:ext cx="10607040" cy="640080"/>
+          </a:xfrm>
+          <a:prstGeom prst="rect">
+            <a:avLst/>
+          </a:prstGeom>
+          <a:noFill/>
+          <a:ln/>
+        </p:spPr>
+        <p:txBody>
+          <a:bodyPr wrap="square" lIns="0" tIns="0" rIns="0" bIns="0" rtlCol="0" anchor="ctr"/>
+          <a:lstStyle/>
+          <a:p>
+            <a:pPr indent="0" marL="0">
+              <a:lnSpc>
+                <a:spcPct val="115000"/>
+              </a:lnSpc>
+              <a:buNone/>
+            </a:pPr>
+            <a:r>
+              <a:rPr lang="en-US" sz="1600" dirty="0">
+                <a:solidFill>
+                  <a:srgbClr val="12201A"/>
+                </a:solidFill>
+                <a:latin typeface="Calibri" pitchFamily="34" charset="0"/>
+                <a:ea typeface="Calibri" pitchFamily="34" charset="-122"/>
+                <a:cs typeface="Calibri" pitchFamily="34" charset="-120"/>
+              </a:rPr>
+              <a:t>Simple, aligned economics. Agripals takes a small cut of everything it moves — and the cheaper it makes food, the more that moves.</a:t>
+            </a:r>
+            <a:endParaRPr lang="en-US" sz="1600" dirty="0"/>
+          </a:p>
+        </p:txBody>
+      </p:sp>
+      <p:sp>
+        <p:nvSpPr>
+          <p:cNvPr id="5" name="Shape 3"/>
+          <p:cNvSpPr/>
+          <p:nvPr/>
+        </p:nvSpPr>
+        <p:spPr>
+          <a:xfrm>
+            <a:off x="658368" y="2743200"/>
+            <a:ext cx="3383280" cy="3017520"/>
+          </a:xfrm>
+          <a:prstGeom prst="roundRect">
+            <a:avLst>
+              <a:gd name="adj" fmla="val 4242"/>
+            </a:avLst>
+          </a:prstGeom>
+          <a:solidFill>
+            <a:srgbClr val="FFFFFF"/>
+          </a:solidFill>
+          <a:ln/>
+          <a:effectLst>
+            <a:outerShdw sx="100000" sy="100000" kx="0" ky="0" algn="bl" rotWithShape="0" blurRad="127000" dist="38100" dir="5400000">
+              <a:srgbClr val="1B3A2E">
+                <a:alpha val="16000"/>
+              </a:srgbClr>
+            </a:outerShdw>
+          </a:effectLst>
+        </p:spPr>
+        <p:txBody>
+          <a:bodyPr/>
+          <a:p/>
+        </p:txBody>
+      </p:sp>
+      <p:sp>
+        <p:nvSpPr>
+          <p:cNvPr id="6" name="Shape 4"/>
+          <p:cNvSpPr/>
+          <p:nvPr/>
+        </p:nvSpPr>
+        <p:spPr>
+          <a:xfrm>
+            <a:off x="978408" y="3090672"/>
+            <a:ext cx="777240" cy="777240"/>
+          </a:xfrm>
+          <a:prstGeom prst="ellipse">
+            <a:avLst/>
+          </a:prstGeom>
+          <a:solidFill>
+            <a:srgbClr val="2E8564"/>
+          </a:solidFill>
+          <a:ln/>
+        </p:spPr>
+        <p:txBody>
+          <a:bodyPr/>
+          <a:p/>
+        </p:txBody>
+      </p:sp>
+      <p:sp>
+        <p:nvSpPr>
+          <p:cNvPr id="7" name="Text 5"/>
+          <p:cNvSpPr/>
+          <p:nvPr/>
+        </p:nvSpPr>
+        <p:spPr>
+          <a:xfrm>
+            <a:off x="978408" y="3090672"/>
+            <a:ext cx="777240" cy="777240"/>
+          </a:xfrm>
+          <a:prstGeom prst="rect">
+            <a:avLst/>
+          </a:prstGeom>
+          <a:noFill/>
+          <a:ln/>
+        </p:spPr>
+        <p:txBody>
+          <a:bodyPr wrap="square" lIns="0" tIns="0" rIns="0" bIns="0" rtlCol="0" anchor="ctr"/>
+          <a:lstStyle/>
+          <a:p>
+            <a:pPr algn="ctr" indent="0" marL="0">
+              <a:buNone/>
+            </a:pPr>
+            <a:r>
+              <a:rPr lang="en-US" sz="3000" b="1" dirty="0">
+                <a:solidFill>
+                  <a:srgbClr val="FFFFFF"/>
+                </a:solidFill>
+                <a:latin typeface="Calibri" pitchFamily="34" charset="0"/>
+                <a:ea typeface="Calibri" pitchFamily="34" charset="-122"/>
+                <a:cs typeface="Calibri" pitchFamily="34" charset="-120"/>
+              </a:rPr>
+              <a:t>1</a:t>
+            </a:r>
+            <a:endParaRPr lang="en-US" sz="3000" dirty="0"/>
+          </a:p>
+        </p:txBody>
+      </p:sp>
+      <p:sp>
+        <p:nvSpPr>
+          <p:cNvPr id="8" name="Text 6"/>
+          <p:cNvSpPr/>
+          <p:nvPr/>
+        </p:nvSpPr>
+        <p:spPr>
+          <a:xfrm>
+            <a:off x="1892808" y="3154680"/>
+            <a:ext cx="1920240" cy="320040"/>
+          </a:xfrm>
+          <a:prstGeom prst="rect">
+            <a:avLst/>
+          </a:prstGeom>
+          <a:noFill/>
+          <a:ln/>
+        </p:spPr>
+        <p:txBody>
+          <a:bodyPr wrap="square" lIns="0" tIns="0" rIns="0" bIns="0" rtlCol="0" anchor="ctr"/>
+          <a:lstStyle/>
+          <a:p>
+            <a:pPr indent="0" marL="0">
+              <a:buNone/>
+            </a:pPr>
+            <a:r>
+              <a:rPr lang="en-US" sz="1100" b="1" spc="100" kern="0" dirty="0">
+                <a:solidFill>
+                  <a:srgbClr val="68786F"/>
+                </a:solidFill>
+                <a:latin typeface="Calibri" pitchFamily="34" charset="0"/>
+                <a:ea typeface="Calibri" pitchFamily="34" charset="-122"/>
+                <a:cs typeface="Calibri" pitchFamily="34" charset="-120"/>
+              </a:rPr>
+              <a:t>Take rate</a:t>
+            </a:r>
+            <a:endParaRPr lang="en-US" sz="1100" dirty="0"/>
+          </a:p>
+        </p:txBody>
+      </p:sp>
+      <p:sp>
+        <p:nvSpPr>
+          <p:cNvPr id="9" name="Text 7"/>
+          <p:cNvSpPr/>
+          <p:nvPr/>
+        </p:nvSpPr>
+        <p:spPr>
+          <a:xfrm>
+            <a:off x="1892808" y="3429000"/>
+            <a:ext cx="1920240" cy="457200"/>
+          </a:xfrm>
+          <a:prstGeom prst="rect">
+            <a:avLst/>
+          </a:prstGeom>
+          <a:noFill/>
+          <a:ln/>
+        </p:spPr>
+        <p:txBody>
+          <a:bodyPr wrap="square" lIns="0" tIns="0" rIns="0" bIns="0" rtlCol="0" anchor="ctr"/>
+          <a:lstStyle/>
+          <a:p>
+            <a:pPr indent="0" marL="0">
+              <a:buNone/>
+            </a:pPr>
+            <a:r>
+              <a:rPr lang="en-US" sz="1550" b="1" dirty="0">
+                <a:solidFill>
+                  <a:srgbClr val="123024"/>
+                </a:solidFill>
+                <a:latin typeface="Calibri" pitchFamily="34" charset="0"/>
+                <a:ea typeface="Calibri" pitchFamily="34" charset="-122"/>
+                <a:cs typeface="Calibri" pitchFamily="34" charset="-120"/>
+              </a:rPr>
+              <a:t>5% of every order</a:t>
+            </a:r>
+            <a:endParaRPr lang="en-US" sz="1550" dirty="0"/>
+          </a:p>
+        </p:txBody>
+      </p:sp>
+      <p:sp>
+        <p:nvSpPr>
+          <p:cNvPr id="10" name="Text 8"/>
+          <p:cNvSpPr/>
+          <p:nvPr/>
+        </p:nvSpPr>
+        <p:spPr>
+          <a:xfrm>
+            <a:off x="978408" y="4251960"/>
+            <a:ext cx="2743200" cy="1280160"/>
+          </a:xfrm>
+          <a:prstGeom prst="rect">
+            <a:avLst/>
+          </a:prstGeom>
+          <a:noFill/>
+          <a:ln/>
+        </p:spPr>
+        <p:txBody>
+          <a:bodyPr wrap="square" lIns="0" tIns="0" rIns="0" bIns="0" rtlCol="0" anchor="ctr"/>
+          <a:lstStyle/>
+          <a:p>
+            <a:pPr indent="0" marL="0">
+              <a:lnSpc>
+                <a:spcPct val="118000"/>
+              </a:lnSpc>
+              <a:buNone/>
+            </a:pPr>
+            <a:r>
+              <a:rPr lang="en-US" sz="1280" dirty="0">
+                <a:solidFill>
+                  <a:srgbClr val="68786F"/>
+                </a:solidFill>
+                <a:latin typeface="Calibri" pitchFamily="34" charset="0"/>
+                <a:ea typeface="Calibri" pitchFamily="34" charset="-122"/>
+                <a:cs typeface="Calibri" pitchFamily="34" charset="-120"/>
+              </a:rPr>
+              <a:t>Agripals takes ~5% of each order's value (GMV). No subscription — we only earn when the kitchen saves.</a:t>
+            </a:r>
+            <a:endParaRPr lang="en-US" sz="1280" dirty="0"/>
+          </a:p>
+        </p:txBody>
+      </p:sp>
+      <p:sp>
+        <p:nvSpPr>
+          <p:cNvPr id="11" name="Shape 9"/>
+          <p:cNvSpPr/>
+          <p:nvPr/>
+        </p:nvSpPr>
+        <p:spPr>
+          <a:xfrm>
+            <a:off x="4334256" y="2743200"/>
+            <a:ext cx="3383280" cy="3017520"/>
+          </a:xfrm>
+          <a:prstGeom prst="roundRect">
+            <a:avLst>
+              <a:gd name="adj" fmla="val 4242"/>
+            </a:avLst>
+          </a:prstGeom>
+          <a:solidFill>
+            <a:srgbClr val="FFFFFF"/>
+          </a:solidFill>
+          <a:ln/>
+          <a:effectLst>
+            <a:outerShdw sx="100000" sy="100000" kx="0" ky="0" algn="bl" rotWithShape="0" blurRad="127000" dist="38100" dir="5400000">
+              <a:srgbClr val="1B3A2E">
+                <a:alpha val="16000"/>
+              </a:srgbClr>
+            </a:outerShdw>
+          </a:effectLst>
+        </p:spPr>
+        <p:txBody>
+          <a:bodyPr/>
+          <a:p/>
+        </p:txBody>
+      </p:sp>
+      <p:sp>
+        <p:nvSpPr>
+          <p:cNvPr id="12" name="Shape 10"/>
+          <p:cNvSpPr/>
+          <p:nvPr/>
+        </p:nvSpPr>
+        <p:spPr>
+          <a:xfrm>
+            <a:off x="4654296" y="3090672"/>
+            <a:ext cx="777240" cy="777240"/>
+          </a:xfrm>
+          <a:prstGeom prst="ellipse">
+            <a:avLst/>
+          </a:prstGeom>
+          <a:solidFill>
+            <a:srgbClr val="37A278"/>
+          </a:solidFill>
+          <a:ln/>
+        </p:spPr>
+        <p:txBody>
+          <a:bodyPr/>
+          <a:p/>
+        </p:txBody>
+      </p:sp>
+      <p:sp>
+        <p:nvSpPr>
+          <p:cNvPr id="13" name="Text 11"/>
+          <p:cNvSpPr/>
+          <p:nvPr/>
+        </p:nvSpPr>
+        <p:spPr>
+          <a:xfrm>
+            <a:off x="4654296" y="3090672"/>
+            <a:ext cx="777240" cy="777240"/>
+          </a:xfrm>
+          <a:prstGeom prst="rect">
+            <a:avLst/>
+          </a:prstGeom>
+          <a:noFill/>
+          <a:ln/>
+        </p:spPr>
+        <p:txBody>
+          <a:bodyPr wrap="square" lIns="0" tIns="0" rIns="0" bIns="0" rtlCol="0" anchor="ctr"/>
+          <a:lstStyle/>
+          <a:p>
+            <a:pPr algn="ctr" indent="0" marL="0">
+              <a:buNone/>
+            </a:pPr>
+            <a:r>
+              <a:rPr lang="en-US" sz="3000" b="1" dirty="0">
+                <a:solidFill>
+                  <a:srgbClr val="FFFFFF"/>
+                </a:solidFill>
+                <a:latin typeface="Calibri" pitchFamily="34" charset="0"/>
+                <a:ea typeface="Calibri" pitchFamily="34" charset="-122"/>
+                <a:cs typeface="Calibri" pitchFamily="34" charset="-120"/>
+              </a:rPr>
+              <a:t>2</a:t>
+            </a:r>
+            <a:endParaRPr lang="en-US" sz="3000" dirty="0"/>
+          </a:p>
+        </p:txBody>
+      </p:sp>
+      <p:sp>
+        <p:nvSpPr>
+          <p:cNvPr id="14" name="Text 12"/>
+          <p:cNvSpPr/>
+          <p:nvPr/>
+        </p:nvSpPr>
+        <p:spPr>
+          <a:xfrm>
+            <a:off x="5568696" y="3154680"/>
+            <a:ext cx="1920240" cy="320040"/>
+          </a:xfrm>
+          <a:prstGeom prst="rect">
+            <a:avLst/>
+          </a:prstGeom>
+          <a:noFill/>
+          <a:ln/>
+        </p:spPr>
+        <p:txBody>
+          <a:bodyPr wrap="square" lIns="0" tIns="0" rIns="0" bIns="0" rtlCol="0" anchor="ctr"/>
+          <a:lstStyle/>
+          <a:p>
+            <a:pPr indent="0" marL="0">
+              <a:buNone/>
+            </a:pPr>
+            <a:r>
+              <a:rPr lang="en-US" sz="1100" b="1" spc="100" kern="0" dirty="0">
+                <a:solidFill>
+                  <a:srgbClr val="68786F"/>
+                </a:solidFill>
+                <a:latin typeface="Calibri" pitchFamily="34" charset="0"/>
+                <a:ea typeface="Calibri" pitchFamily="34" charset="-122"/>
+                <a:cs typeface="Calibri" pitchFamily="34" charset="-120"/>
+              </a:rPr>
+              <a:t>Credit float</a:t>
+            </a:r>
+            <a:endParaRPr lang="en-US" sz="1100" dirty="0"/>
+          </a:p>
+        </p:txBody>
+      </p:sp>
+      <p:sp>
+        <p:nvSpPr>
+          <p:cNvPr id="15" name="Text 13"/>
+          <p:cNvSpPr/>
+          <p:nvPr/>
+        </p:nvSpPr>
+        <p:spPr>
+          <a:xfrm>
+            <a:off x="5568696" y="3429000"/>
+            <a:ext cx="1920240" cy="457200"/>
+          </a:xfrm>
+          <a:prstGeom prst="rect">
+            <a:avLst/>
+          </a:prstGeom>
+          <a:noFill/>
+          <a:ln/>
+        </p:spPr>
+        <p:txBody>
+          <a:bodyPr wrap="square" lIns="0" tIns="0" rIns="0" bIns="0" rtlCol="0" anchor="ctr"/>
+          <a:lstStyle/>
+          <a:p>
+            <a:pPr indent="0" marL="0">
+              <a:buNone/>
+            </a:pPr>
+            <a:r>
+              <a:rPr lang="en-US" sz="1550" b="1" dirty="0">
+                <a:solidFill>
+                  <a:srgbClr val="123024"/>
+                </a:solidFill>
+                <a:latin typeface="Calibri" pitchFamily="34" charset="0"/>
+                <a:ea typeface="Calibri" pitchFamily="34" charset="-122"/>
+                <a:cs typeface="Calibri" pitchFamily="34" charset="-120"/>
+              </a:rPr>
+              <a:t>We finance the middle</a:t>
+            </a:r>
+            <a:endParaRPr lang="en-US" sz="1550" dirty="0"/>
+          </a:p>
+        </p:txBody>
+      </p:sp>
+      <p:sp>
+        <p:nvSpPr>
+          <p:cNvPr id="16" name="Text 14"/>
+          <p:cNvSpPr/>
+          <p:nvPr/>
+        </p:nvSpPr>
+        <p:spPr>
+          <a:xfrm>
+            <a:off x="4654296" y="4251960"/>
+            <a:ext cx="2743200" cy="1280160"/>
+          </a:xfrm>
+          <a:prstGeom prst="rect">
+            <a:avLst/>
+          </a:prstGeom>
+          <a:noFill/>
+          <a:ln/>
+        </p:spPr>
+        <p:txBody>
+          <a:bodyPr wrap="square" lIns="0" tIns="0" rIns="0" bIns="0" rtlCol="0" anchor="ctr"/>
+          <a:lstStyle/>
+          <a:p>
+            <a:pPr indent="0" marL="0">
+              <a:lnSpc>
+                <a:spcPct val="118000"/>
+              </a:lnSpc>
+              <a:buNone/>
+            </a:pPr>
+            <a:r>
+              <a:rPr lang="en-US" sz="1280" dirty="0">
+                <a:solidFill>
+                  <a:srgbClr val="68786F"/>
+                </a:solidFill>
+                <a:latin typeface="Calibri" pitchFamily="34" charset="0"/>
+                <a:ea typeface="Calibri" pitchFamily="34" charset="-122"/>
+                <a:cs typeface="Calibri" pitchFamily="34" charset="-120"/>
+              </a:rPr>
+              <a:t>Farms don't want to carry credit. We pay them on delivery and bill kitchens on terms — earning a financing margin.</a:t>
+            </a:r>
+            <a:endParaRPr lang="en-US" sz="1280" dirty="0"/>
+          </a:p>
+        </p:txBody>
+      </p:sp>
+      <p:sp>
+        <p:nvSpPr>
+          <p:cNvPr id="17" name="Shape 15"/>
+          <p:cNvSpPr/>
+          <p:nvPr/>
+        </p:nvSpPr>
+        <p:spPr>
+          <a:xfrm>
+            <a:off x="8010144" y="2743200"/>
+            <a:ext cx="3383280" cy="3017520"/>
+          </a:xfrm>
+          <a:prstGeom prst="roundRect">
+            <a:avLst>
+              <a:gd name="adj" fmla="val 4242"/>
+            </a:avLst>
+          </a:prstGeom>
+          <a:solidFill>
+            <a:srgbClr val="FFFFFF"/>
+          </a:solidFill>
+          <a:ln/>
+          <a:effectLst>
+            <a:outerShdw sx="100000" sy="100000" kx="0" ky="0" algn="bl" rotWithShape="0" blurRad="127000" dist="38100" dir="5400000">
+              <a:srgbClr val="1B3A2E">
+                <a:alpha val="16000"/>
+              </a:srgbClr>
+            </a:outerShdw>
+          </a:effectLst>
+        </p:spPr>
+        <p:txBody>
+          <a:bodyPr/>
+          <a:p/>
+        </p:txBody>
+      </p:sp>
+      <p:sp>
+        <p:nvSpPr>
+          <p:cNvPr id="18" name="Shape 16"/>
+          <p:cNvSpPr/>
+          <p:nvPr/>
+        </p:nvSpPr>
+        <p:spPr>
+          <a:xfrm>
+            <a:off x="8330184" y="3090672"/>
+            <a:ext cx="777240" cy="777240"/>
+          </a:xfrm>
+          <a:prstGeom prst="ellipse">
+            <a:avLst/>
+          </a:prstGeom>
+          <a:solidFill>
+            <a:srgbClr val="4CC499"/>
+          </a:solidFill>
+          <a:ln/>
+        </p:spPr>
+        <p:txBody>
+          <a:bodyPr/>
+          <a:p/>
+        </p:txBody>
+      </p:sp>
+      <p:sp>
+        <p:nvSpPr>
+          <p:cNvPr id="19" name="Text 17"/>
+          <p:cNvSpPr/>
+          <p:nvPr/>
+        </p:nvSpPr>
+        <p:spPr>
+          <a:xfrm>
+            <a:off x="8330184" y="3090672"/>
+            <a:ext cx="777240" cy="777240"/>
+          </a:xfrm>
+          <a:prstGeom prst="rect">
+            <a:avLst/>
+          </a:prstGeom>
+          <a:noFill/>
+          <a:ln/>
+        </p:spPr>
+        <p:txBody>
+          <a:bodyPr wrap="square" lIns="0" tIns="0" rIns="0" bIns="0" rtlCol="0" anchor="ctr"/>
+          <a:lstStyle/>
+          <a:p>
+            <a:pPr algn="ctr" indent="0" marL="0">
+              <a:buNone/>
+            </a:pPr>
+            <a:r>
+              <a:rPr lang="en-US" sz="3000" b="1" dirty="0">
+                <a:solidFill>
+                  <a:srgbClr val="FFFFFF"/>
+                </a:solidFill>
+                <a:latin typeface="Calibri" pitchFamily="34" charset="0"/>
+                <a:ea typeface="Calibri" pitchFamily="34" charset="-122"/>
+                <a:cs typeface="Calibri" pitchFamily="34" charset="-120"/>
+              </a:rPr>
+              <a:t>3</a:t>
+            </a:r>
+            <a:endParaRPr lang="en-US" sz="3000" dirty="0"/>
+          </a:p>
+        </p:txBody>
+      </p:sp>
+      <p:sp>
+        <p:nvSpPr>
+          <p:cNvPr id="20" name="Text 18"/>
+          <p:cNvSpPr/>
+          <p:nvPr/>
+        </p:nvSpPr>
+        <p:spPr>
+          <a:xfrm>
+            <a:off x="9244584" y="3154680"/>
+            <a:ext cx="1920240" cy="320040"/>
+          </a:xfrm>
+          <a:prstGeom prst="rect">
+            <a:avLst/>
+          </a:prstGeom>
+          <a:noFill/>
+          <a:ln/>
+        </p:spPr>
+        <p:txBody>
+          <a:bodyPr wrap="square" lIns="0" tIns="0" rIns="0" bIns="0" rtlCol="0" anchor="ctr"/>
+          <a:lstStyle/>
+          <a:p>
+            <a:pPr indent="0" marL="0">
+              <a:buNone/>
+            </a:pPr>
+            <a:r>
+              <a:rPr lang="en-US" sz="1100" b="1" spc="100" kern="0" dirty="0">
+                <a:solidFill>
+                  <a:srgbClr val="68786F"/>
+                </a:solidFill>
+                <a:latin typeface="Calibri" pitchFamily="34" charset="0"/>
+                <a:ea typeface="Calibri" pitchFamily="34" charset="-122"/>
+                <a:cs typeface="Calibri" pitchFamily="34" charset="-120"/>
+              </a:rPr>
+              <a:t>Network data</a:t>
+            </a:r>
+            <a:endParaRPr lang="en-US" sz="1100" dirty="0"/>
+          </a:p>
+        </p:txBody>
+      </p:sp>
+      <p:sp>
+        <p:nvSpPr>
+          <p:cNvPr id="21" name="Text 19"/>
+          <p:cNvSpPr/>
+          <p:nvPr/>
+        </p:nvSpPr>
+        <p:spPr>
+          <a:xfrm>
+            <a:off x="9244584" y="3429000"/>
+            <a:ext cx="1920240" cy="457200"/>
+          </a:xfrm>
+          <a:prstGeom prst="rect">
+            <a:avLst/>
+          </a:prstGeom>
+          <a:noFill/>
+          <a:ln/>
+        </p:spPr>
+        <p:txBody>
+          <a:bodyPr wrap="square" lIns="0" tIns="0" rIns="0" bIns="0" rtlCol="0" anchor="ctr"/>
+          <a:lstStyle/>
+          <a:p>
+            <a:pPr indent="0" marL="0">
+              <a:buNone/>
+            </a:pPr>
+            <a:r>
+              <a:rPr lang="en-US" sz="1550" b="1" dirty="0">
+                <a:solidFill>
+                  <a:srgbClr val="123024"/>
+                </a:solidFill>
+                <a:latin typeface="Calibri" pitchFamily="34" charset="0"/>
+                <a:ea typeface="Calibri" pitchFamily="34" charset="-122"/>
+                <a:cs typeface="Calibri" pitchFamily="34" charset="-120"/>
+              </a:rPr>
+              <a:t>It compounds</a:t>
+            </a:r>
+            <a:endParaRPr lang="en-US" sz="1550" dirty="0"/>
+          </a:p>
+        </p:txBody>
+      </p:sp>
+      <p:sp>
+        <p:nvSpPr>
+          <p:cNvPr id="22" name="Text 20"/>
+          <p:cNvSpPr/>
+          <p:nvPr/>
+        </p:nvSpPr>
+        <p:spPr>
+          <a:xfrm>
+            <a:off x="8330184" y="4251960"/>
+            <a:ext cx="2743200" cy="1280160"/>
+          </a:xfrm>
+          <a:prstGeom prst="rect">
+            <a:avLst/>
+          </a:prstGeom>
+          <a:noFill/>
+          <a:ln/>
+        </p:spPr>
+        <p:txBody>
+          <a:bodyPr wrap="square" lIns="0" tIns="0" rIns="0" bIns="0" rtlCol="0" anchor="ctr"/>
+          <a:lstStyle/>
+          <a:p>
+            <a:pPr indent="0" marL="0">
+              <a:lnSpc>
+                <a:spcPct val="118000"/>
+              </a:lnSpc>
+              <a:buNone/>
+            </a:pPr>
+            <a:r>
+              <a:rPr lang="en-US" sz="1280" dirty="0">
+                <a:solidFill>
+                  <a:srgbClr val="68786F"/>
+                </a:solidFill>
+                <a:latin typeface="Calibri" pitchFamily="34" charset="0"/>
+                <a:ea typeface="Calibri" pitchFamily="34" charset="-122"/>
+                <a:cs typeface="Calibri" pitchFamily="34" charset="-120"/>
+              </a:rPr>
+              <a:t>Every order sharpens pricing, grading and demand — better matches over time, and a moat that widens with volume.</a:t>
+            </a:r>
+            <a:endParaRPr lang="en-US" sz="1280" dirty="0"/>
+          </a:p>
+        </p:txBody>
+      </p:sp>
+      <p:sp>
+        <p:nvSpPr>
+          <p:cNvPr id="23" name="Text 21"/>
+          <p:cNvSpPr/>
+          <p:nvPr/>
+        </p:nvSpPr>
+        <p:spPr>
+          <a:xfrm>
+            <a:off x="11183112" y="6355080"/>
+            <a:ext cx="548640" cy="274320"/>
+          </a:xfrm>
+          <a:prstGeom prst="rect">
+            <a:avLst/>
+          </a:prstGeom>
+          <a:noFill/>
+          <a:ln/>
+        </p:spPr>
+        <p:txBody>
+          <a:bodyPr wrap="square" lIns="0" tIns="0" rIns="0" bIns="0" rtlCol="0" anchor="ctr"/>
+          <a:lstStyle/>
+          <a:p>
+            <a:pPr algn="r" indent="0" marL="0">
+              <a:buNone/>
+            </a:pPr>
+            <a:r>
+              <a:rPr lang="en-US" sz="1000" dirty="0">
+                <a:solidFill>
+                  <a:srgbClr val="68786F"/>
+                </a:solidFill>
+                <a:latin typeface="Calibri" pitchFamily="34" charset="0"/>
+                <a:ea typeface="Calibri" pitchFamily="34" charset="-122"/>
+                <a:cs typeface="Calibri" pitchFamily="34" charset="-120"/>
+              </a:rPr>
+              <a:t>11</a:t>
+            </a:r>
+            <a:endParaRPr lang="en-US" sz="1000" dirty="0"/>
+          </a:p>
+        </p:txBody>
+      </p:sp>
+      <p:sp>
+        <p:nvSpPr>
+          <p:cNvPr id="24" name="Text 22"/>
+          <p:cNvSpPr/>
+          <p:nvPr/>
+        </p:nvSpPr>
+        <p:spPr>
+          <a:xfrm>
+            <a:off x="658368" y="6355080"/>
+            <a:ext cx="2743200" cy="274320"/>
+          </a:xfrm>
+          <a:prstGeom prst="rect">
+            <a:avLst/>
+          </a:prstGeom>
+          <a:noFill/>
+          <a:ln/>
+        </p:spPr>
+        <p:txBody>
+          <a:bodyPr wrap="square" lIns="0" tIns="0" rIns="0" bIns="0" rtlCol="0" anchor="ctr"/>
+          <a:lstStyle/>
+          <a:p>
+            <a:pPr indent="0" marL="0">
+              <a:buNone/>
+            </a:pPr>
+            <a:r>
+              <a:rPr lang="en-US" sz="1000" b="1" dirty="0">
+                <a:solidFill>
+                  <a:srgbClr val="68786F"/>
+                </a:solidFill>
+                <a:latin typeface="Calibri" pitchFamily="34" charset="0"/>
+                <a:ea typeface="Calibri" pitchFamily="34" charset="-122"/>
+                <a:cs typeface="Calibri" pitchFamily="34" charset="-120"/>
+              </a:rPr>
+              <a:t>Agripals</a:t>
+            </a:r>
+            <a:endParaRPr lang="en-US" sz="1000" dirty="0"/>
+          </a:p>
+        </p:txBody>
+      </p:sp>
+    </p:spTree>
+  </p:cSld>
+  <p:clrMapOvr>
+    <a:masterClrMapping/>
+  </p:clrMapOvr>
+</p:sld>
+</file>
+
+<file path=ppt/slides/slide12.xml><?xml version="1.0" encoding="utf-8"?>
 <p:sld xmlns:a="http://schemas.openxmlformats.org/drawingml/2006/main" xmlns:r="http://schemas.openxmlformats.org/officeDocument/2006/relationships" xmlns:p="http://schemas.openxmlformats.org/presentationml/2006/main">
   <p:cSld name="Slide 3">
     <p:bg>
@@ -3767,7 +4653,7 @@
                 <a:ea typeface="Calibri" pitchFamily="34" charset="-122"/>
                 <a:cs typeface="Calibri" pitchFamily="34" charset="-120"/>
               </a:rPr>
-              <a:t>11</a:t>
+              <a:t>12</a:t>
             </a:r>
             <a:endParaRPr lang="en-US" sz="1000" dirty="0"/>
           </a:p>
@@ -3820,7 +4706,7 @@
 </p:sld>
 </file>
 
-<file path=ppt/slides/slide12.xml><?xml version="1.0" encoding="utf-8"?>
+<file path=ppt/slides/slide13.xml><?xml version="1.0" encoding="utf-8"?>
 <p:sld xmlns:a="http://schemas.openxmlformats.org/drawingml/2006/main" xmlns:r="http://schemas.openxmlformats.org/officeDocument/2006/relationships" xmlns:p="http://schemas.openxmlformats.org/presentationml/2006/main">
   <p:cSld name="Slide 10">
     <p:bg>
@@ -4350,7 +5236,7 @@
                 <a:ea typeface="Calibri" pitchFamily="34" charset="-122"/>
                 <a:cs typeface="Calibri" pitchFamily="34" charset="-120"/>
               </a:rPr>
-              <a:t>12</a:t>
+              <a:t>13</a:t>
             </a:r>
             <a:endParaRPr lang="en-US" sz="1000" dirty="0"/>
           </a:p>
@@ -4403,7 +5289,7 @@
 </p:sld>
 </file>
 
-<file path=ppt/slides/slide13.xml><?xml version="1.0" encoding="utf-8"?>
+<file path=ppt/slides/slide14.xml><?xml version="1.0" encoding="utf-8"?>
 <p:sld xmlns:a="http://schemas.openxmlformats.org/drawingml/2006/main" xmlns:r="http://schemas.openxmlformats.org/officeDocument/2006/relationships" xmlns:p="http://schemas.openxmlformats.org/presentationml/2006/main">
   <p:cSld name="Slide 11">
     <p:bg>
@@ -5067,7 +5953,7 @@
                 <a:ea typeface="Calibri" pitchFamily="34" charset="-122"/>
                 <a:cs typeface="Calibri" pitchFamily="34" charset="-120"/>
               </a:rPr>
-              <a:t>13</a:t>
+              <a:t>14</a:t>
             </a:r>
             <a:endParaRPr lang="en-US" sz="1000" dirty="0"/>
           </a:p>
@@ -5120,7 +6006,7 @@
 </p:sld>
 </file>
 
-<file path=ppt/slides/slide14.xml><?xml version="1.0" encoding="utf-8"?>
+<file path=ppt/slides/slide15.xml><?xml version="1.0" encoding="utf-8"?>
 <p:sld xmlns:a="http://schemas.openxmlformats.org/drawingml/2006/main" xmlns:r="http://schemas.openxmlformats.org/officeDocument/2006/relationships" xmlns:p="http://schemas.openxmlformats.org/presentationml/2006/main">
   <p:cSld name="Slide 12">
     <p:bg>
@@ -5674,7 +6560,7 @@
                 <a:ea typeface="Calibri" pitchFamily="34" charset="-122"/>
                 <a:cs typeface="Calibri" pitchFamily="34" charset="-120"/>
               </a:rPr>
-              <a:t>14</a:t>
+              <a:t>15</a:t>
             </a:r>
             <a:endParaRPr lang="en-US" sz="1000" dirty="0"/>
           </a:p>
@@ -5727,7 +6613,7 @@
 </p:sld>
 </file>
 
-<file path=ppt/slides/slide15.xml><?xml version="1.0" encoding="utf-8"?>
+<file path=ppt/slides/slide16.xml><?xml version="1.0" encoding="utf-8"?>
 <p:sld xmlns:a="http://schemas.openxmlformats.org/drawingml/2006/main" xmlns:r="http://schemas.openxmlformats.org/officeDocument/2006/relationships" xmlns:p="http://schemas.openxmlformats.org/presentationml/2006/main">
   <p:cSld name="Slide 13">
     <p:bg>
@@ -6351,7 +7237,7 @@
                 <a:ea typeface="Calibri" pitchFamily="34" charset="-122"/>
                 <a:cs typeface="Calibri" pitchFamily="34" charset="-120"/>
               </a:rPr>
-              <a:t>15</a:t>
+              <a:t>16</a:t>
             </a:r>
             <a:endParaRPr lang="en-US" sz="1000" dirty="0"/>
           </a:p>
@@ -6404,7 +7290,7 @@
 </p:sld>
 </file>
 
-<file path=ppt/slides/slide16.xml><?xml version="1.0" encoding="utf-8"?>
+<file path=ppt/slides/slide17.xml><?xml version="1.0" encoding="utf-8"?>
 <p:sld xmlns:a="http://schemas.openxmlformats.org/drawingml/2006/main" xmlns:r="http://schemas.openxmlformats.org/officeDocument/2006/relationships" xmlns:p="http://schemas.openxmlformats.org/presentationml/2006/main">
   <p:cSld name="Slide 14">
     <p:bg>
@@ -10480,6 +11366,887 @@
 
 <file path=ppt/slides/slide8.xml><?xml version="1.0" encoding="utf-8"?>
 <p:sld xmlns:a="http://schemas.openxmlformats.org/drawingml/2006/main" xmlns:r="http://schemas.openxmlformats.org/officeDocument/2006/relationships" xmlns:p="http://schemas.openxmlformats.org/presentationml/2006/main">
+  <p:cSld name="Slide 9">
+    <p:bg>
+      <p:bgPr>
+        <a:solidFill>
+          <a:srgbClr val="F4F7F6"/>
+        </a:solidFill>
+      </p:bgPr>
+    </p:bg>
+    <p:spTree>
+      <p:nvGrpSpPr>
+        <p:cNvPr id="1" name=""/>
+        <p:cNvGrpSpPr/>
+        <p:nvPr/>
+      </p:nvGrpSpPr>
+      <p:grpSpPr>
+        <a:xfrm>
+          <a:off x="0" y="0"/>
+          <a:ext cx="0" cy="0"/>
+          <a:chOff x="0" y="0"/>
+          <a:chExt cx="0" cy="0"/>
+        </a:xfrm>
+      </p:grpSpPr>
+      <p:sp>
+        <p:nvSpPr>
+          <p:cNvPr id="2" name="Text 0"/>
+          <p:cNvSpPr/>
+          <p:nvPr/>
+        </p:nvSpPr>
+        <p:spPr>
+          <a:xfrm>
+            <a:off x="658368" y="457200"/>
+            <a:ext cx="8229600" cy="320040"/>
+          </a:xfrm>
+          <a:prstGeom prst="rect">
+            <a:avLst/>
+          </a:prstGeom>
+          <a:noFill/>
+          <a:ln/>
+        </p:spPr>
+        <p:txBody>
+          <a:bodyPr wrap="square" lIns="0" tIns="0" rIns="0" bIns="0" rtlCol="0" anchor="ctr"/>
+          <a:lstStyle/>
+          <a:p>
+            <a:pPr algn="l" indent="0" marL="0">
+              <a:buNone/>
+            </a:pPr>
+            <a:r>
+              <a:rPr lang="en-US" sz="1250" b="1" spc="300" kern="0" dirty="0">
+                <a:solidFill>
+                  <a:srgbClr val="37A278"/>
+                </a:solidFill>
+                <a:latin typeface="Calibri" pitchFamily="34" charset="0"/>
+                <a:ea typeface="Calibri" pitchFamily="34" charset="-122"/>
+                <a:cs typeface="Calibri" pitchFamily="34" charset="-120"/>
+              </a:rPr>
+              <a:t>THE UNLOCK</a:t>
+            </a:r>
+            <a:endParaRPr lang="en-US" sz="1250" dirty="0"/>
+          </a:p>
+        </p:txBody>
+      </p:sp>
+      <p:sp>
+        <p:nvSpPr>
+          <p:cNvPr id="3" name="Text 1"/>
+          <p:cNvSpPr/>
+          <p:nvPr/>
+        </p:nvSpPr>
+        <p:spPr>
+          <a:xfrm>
+            <a:off x="658368" y="841248"/>
+            <a:ext cx="10872216" cy="1051560"/>
+          </a:xfrm>
+          <a:prstGeom prst="rect">
+            <a:avLst/>
+          </a:prstGeom>
+          <a:noFill/>
+          <a:ln/>
+        </p:spPr>
+        <p:txBody>
+          <a:bodyPr wrap="square" lIns="0" tIns="0" rIns="0" bIns="0" rtlCol="0" anchor="ctr"/>
+          <a:lstStyle/>
+          <a:p>
+            <a:pPr algn="l" indent="0" marL="0">
+              <a:lnSpc>
+                <a:spcPct val="100000"/>
+              </a:lnSpc>
+              <a:buNone/>
+            </a:pPr>
+            <a:r>
+              <a:rPr lang="en-US" sz="3400" b="1" dirty="0">
+                <a:solidFill>
+                  <a:srgbClr val="123024"/>
+                </a:solidFill>
+                <a:latin typeface="Calibri" pitchFamily="34" charset="0"/>
+                <a:ea typeface="Calibri" pitchFamily="34" charset="-122"/>
+                <a:cs typeface="Calibri" pitchFamily="34" charset="-120"/>
+              </a:rPr>
+              <a:t>An online-only, AI-native wholesaler.</a:t>
+            </a:r>
+            <a:endParaRPr lang="en-US" sz="3400" dirty="0"/>
+          </a:p>
+        </p:txBody>
+      </p:sp>
+      <p:sp>
+        <p:nvSpPr>
+          <p:cNvPr id="4" name="Text 2"/>
+          <p:cNvSpPr/>
+          <p:nvPr/>
+        </p:nvSpPr>
+        <p:spPr>
+          <a:xfrm>
+            <a:off x="658368" y="1828800"/>
+            <a:ext cx="10607040" cy="640080"/>
+          </a:xfrm>
+          <a:prstGeom prst="rect">
+            <a:avLst/>
+          </a:prstGeom>
+          <a:noFill/>
+          <a:ln/>
+        </p:spPr>
+        <p:txBody>
+          <a:bodyPr wrap="square" lIns="0" tIns="0" rIns="0" bIns="0" rtlCol="0" anchor="ctr"/>
+          <a:lstStyle/>
+          <a:p>
+            <a:pPr indent="0" marL="0">
+              <a:lnSpc>
+                <a:spcPct val="115000"/>
+              </a:lnSpc>
+              <a:buNone/>
+            </a:pPr>
+            <a:r>
+              <a:rPr lang="en-US" sz="1600" dirty="0">
+                <a:solidFill>
+                  <a:srgbClr val="12201A"/>
+                </a:solidFill>
+                <a:latin typeface="Calibri" pitchFamily="34" charset="0"/>
+                <a:ea typeface="Calibri" pitchFamily="34" charset="-122"/>
+                <a:cs typeface="Calibri" pitchFamily="34" charset="-120"/>
+              </a:rPr>
+              <a:t>Wholesalers doubled the price because they owned the last mile and forced chefs onto software they hated. Two AI shifts remove that moat — so we run it all online, with zero trucks and zero warehouses.</a:t>
+            </a:r>
+            <a:endParaRPr lang="en-US" sz="1600" dirty="0"/>
+          </a:p>
+        </p:txBody>
+      </p:sp>
+      <p:sp>
+        <p:nvSpPr>
+          <p:cNvPr id="5" name="Shape 3"/>
+          <p:cNvSpPr/>
+          <p:nvPr/>
+        </p:nvSpPr>
+        <p:spPr>
+          <a:xfrm>
+            <a:off x="658368" y="2743200"/>
+            <a:ext cx="3383280" cy="3017520"/>
+          </a:xfrm>
+          <a:prstGeom prst="roundRect">
+            <a:avLst>
+              <a:gd name="adj" fmla="val 4242"/>
+            </a:avLst>
+          </a:prstGeom>
+          <a:solidFill>
+            <a:srgbClr val="FFFFFF"/>
+          </a:solidFill>
+          <a:ln/>
+          <a:effectLst>
+            <a:outerShdw sx="100000" sy="100000" kx="0" ky="0" algn="bl" rotWithShape="0" blurRad="127000" dist="38100" dir="5400000">
+              <a:srgbClr val="1B3A2E">
+                <a:alpha val="16000"/>
+              </a:srgbClr>
+            </a:outerShdw>
+          </a:effectLst>
+        </p:spPr>
+        <p:txBody>
+          <a:bodyPr/>
+          <a:p/>
+        </p:txBody>
+      </p:sp>
+      <p:sp>
+        <p:nvSpPr>
+          <p:cNvPr id="6" name="Shape 4"/>
+          <p:cNvSpPr/>
+          <p:nvPr/>
+        </p:nvSpPr>
+        <p:spPr>
+          <a:xfrm>
+            <a:off x="978408" y="3090672"/>
+            <a:ext cx="777240" cy="777240"/>
+          </a:xfrm>
+          <a:prstGeom prst="ellipse">
+            <a:avLst/>
+          </a:prstGeom>
+          <a:solidFill>
+            <a:srgbClr val="2E8564"/>
+          </a:solidFill>
+          <a:ln/>
+        </p:spPr>
+        <p:txBody>
+          <a:bodyPr/>
+          <a:p/>
+        </p:txBody>
+      </p:sp>
+      <p:sp>
+        <p:nvSpPr>
+          <p:cNvPr id="7" name="Text 5"/>
+          <p:cNvSpPr/>
+          <p:nvPr/>
+        </p:nvSpPr>
+        <p:spPr>
+          <a:xfrm>
+            <a:off x="978408" y="3090672"/>
+            <a:ext cx="777240" cy="777240"/>
+          </a:xfrm>
+          <a:prstGeom prst="rect">
+            <a:avLst/>
+          </a:prstGeom>
+          <a:noFill/>
+          <a:ln/>
+        </p:spPr>
+        <p:txBody>
+          <a:bodyPr wrap="square" lIns="0" tIns="0" rIns="0" bIns="0" rtlCol="0" anchor="ctr"/>
+          <a:lstStyle/>
+          <a:p>
+            <a:pPr algn="ctr" indent="0" marL="0">
+              <a:buNone/>
+            </a:pPr>
+            <a:r>
+              <a:rPr lang="en-US" sz="3000" b="1" dirty="0">
+                <a:solidFill>
+                  <a:srgbClr val="FFFFFF"/>
+                </a:solidFill>
+                <a:latin typeface="Calibri" pitchFamily="34" charset="0"/>
+                <a:ea typeface="Calibri" pitchFamily="34" charset="-122"/>
+                <a:cs typeface="Calibri" pitchFamily="34" charset="-120"/>
+              </a:rPr>
+              <a:t>1</a:t>
+            </a:r>
+            <a:endParaRPr lang="en-US" sz="3000" dirty="0"/>
+          </a:p>
+        </p:txBody>
+      </p:sp>
+      <p:sp>
+        <p:nvSpPr>
+          <p:cNvPr id="8" name="Text 6"/>
+          <p:cNvSpPr/>
+          <p:nvPr/>
+        </p:nvSpPr>
+        <p:spPr>
+          <a:xfrm>
+            <a:off x="1892808" y="3154680"/>
+            <a:ext cx="1920240" cy="320040"/>
+          </a:xfrm>
+          <a:prstGeom prst="rect">
+            <a:avLst/>
+          </a:prstGeom>
+          <a:noFill/>
+          <a:ln/>
+        </p:spPr>
+        <p:txBody>
+          <a:bodyPr wrap="square" lIns="0" tIns="0" rIns="0" bIns="0" rtlCol="0" anchor="ctr"/>
+          <a:lstStyle/>
+          <a:p>
+            <a:pPr indent="0" marL="0">
+              <a:buNone/>
+            </a:pPr>
+            <a:r>
+              <a:rPr lang="en-US" sz="1100" b="1" spc="100" kern="0" dirty="0">
+                <a:solidFill>
+                  <a:srgbClr val="68786F"/>
+                </a:solidFill>
+                <a:latin typeface="Calibri" pitchFamily="34" charset="0"/>
+                <a:ea typeface="Calibri" pitchFamily="34" charset="-122"/>
+                <a:cs typeface="Calibri" pitchFamily="34" charset="-120"/>
+              </a:rPr>
+              <a:t>The wedge</a:t>
+            </a:r>
+            <a:endParaRPr lang="en-US" sz="1100" dirty="0"/>
+          </a:p>
+        </p:txBody>
+      </p:sp>
+      <p:sp>
+        <p:nvSpPr>
+          <p:cNvPr id="9" name="Text 7"/>
+          <p:cNvSpPr/>
+          <p:nvPr/>
+        </p:nvSpPr>
+        <p:spPr>
+          <a:xfrm>
+            <a:off x="1892808" y="3429000"/>
+            <a:ext cx="1920240" cy="457200"/>
+          </a:xfrm>
+          <a:prstGeom prst="rect">
+            <a:avLst/>
+          </a:prstGeom>
+          <a:noFill/>
+          <a:ln/>
+        </p:spPr>
+        <p:txBody>
+          <a:bodyPr wrap="square" lIns="0" tIns="0" rIns="0" bIns="0" rtlCol="0" anchor="ctr"/>
+          <a:lstStyle/>
+          <a:p>
+            <a:pPr indent="0" marL="0">
+              <a:buNone/>
+            </a:pPr>
+            <a:r>
+              <a:rPr lang="en-US" sz="1550" b="1" dirty="0">
+                <a:solidFill>
+                  <a:srgbClr val="123024"/>
+                </a:solidFill>
+                <a:latin typeface="Calibri" pitchFamily="34" charset="0"/>
+                <a:ea typeface="Calibri" pitchFamily="34" charset="-122"/>
+                <a:cs typeface="Calibri" pitchFamily="34" charset="-120"/>
+              </a:rPr>
+              <a:t>Everyone runs on text</a:t>
+            </a:r>
+            <a:endParaRPr lang="en-US" sz="1550" dirty="0"/>
+          </a:p>
+        </p:txBody>
+      </p:sp>
+      <p:sp>
+        <p:nvSpPr>
+          <p:cNvPr id="10" name="Text 8"/>
+          <p:cNvSpPr/>
+          <p:nvPr/>
+        </p:nvSpPr>
+        <p:spPr>
+          <a:xfrm>
+            <a:off x="978408" y="4251960"/>
+            <a:ext cx="2743200" cy="1280160"/>
+          </a:xfrm>
+          <a:prstGeom prst="rect">
+            <a:avLst/>
+          </a:prstGeom>
+          <a:noFill/>
+          <a:ln/>
+        </p:spPr>
+        <p:txBody>
+          <a:bodyPr wrap="square" lIns="0" tIns="0" rIns="0" bIns="0" rtlCol="0" anchor="ctr"/>
+          <a:lstStyle/>
+          <a:p>
+            <a:pPr indent="0" marL="0">
+              <a:lnSpc>
+                <a:spcPct val="118000"/>
+              </a:lnSpc>
+              <a:buNone/>
+            </a:pPr>
+            <a:r>
+              <a:rPr lang="en-US" sz="1280" dirty="0">
+                <a:solidFill>
+                  <a:srgbClr val="68786F"/>
+                </a:solidFill>
+                <a:latin typeface="Calibri" pitchFamily="34" charset="0"/>
+                <a:ea typeface="Calibri" pitchFamily="34" charset="-122"/>
+                <a:cs typeface="Calibri" pitchFamily="34" charset="-120"/>
+              </a:rPr>
+              <a:t>Farms, drivers and chefs already coordinate their whole day by text. Agripals meets them there — no portal, no app to learn.</a:t>
+            </a:r>
+            <a:endParaRPr lang="en-US" sz="1280" dirty="0"/>
+          </a:p>
+        </p:txBody>
+      </p:sp>
+      <p:sp>
+        <p:nvSpPr>
+          <p:cNvPr id="11" name="Shape 9"/>
+          <p:cNvSpPr/>
+          <p:nvPr/>
+        </p:nvSpPr>
+        <p:spPr>
+          <a:xfrm>
+            <a:off x="4334256" y="2743200"/>
+            <a:ext cx="3383280" cy="3017520"/>
+          </a:xfrm>
+          <a:prstGeom prst="roundRect">
+            <a:avLst>
+              <a:gd name="adj" fmla="val 4242"/>
+            </a:avLst>
+          </a:prstGeom>
+          <a:solidFill>
+            <a:srgbClr val="FFFFFF"/>
+          </a:solidFill>
+          <a:ln/>
+          <a:effectLst>
+            <a:outerShdw sx="100000" sy="100000" kx="0" ky="0" algn="bl" rotWithShape="0" blurRad="127000" dist="38100" dir="5400000">
+              <a:srgbClr val="1B3A2E">
+                <a:alpha val="16000"/>
+              </a:srgbClr>
+            </a:outerShdw>
+          </a:effectLst>
+        </p:spPr>
+        <p:txBody>
+          <a:bodyPr/>
+          <a:p/>
+        </p:txBody>
+      </p:sp>
+      <p:sp>
+        <p:nvSpPr>
+          <p:cNvPr id="12" name="Shape 10"/>
+          <p:cNvSpPr/>
+          <p:nvPr/>
+        </p:nvSpPr>
+        <p:spPr>
+          <a:xfrm>
+            <a:off x="4654296" y="3090672"/>
+            <a:ext cx="777240" cy="777240"/>
+          </a:xfrm>
+          <a:prstGeom prst="ellipse">
+            <a:avLst/>
+          </a:prstGeom>
+          <a:solidFill>
+            <a:srgbClr val="37A278"/>
+          </a:solidFill>
+          <a:ln/>
+        </p:spPr>
+        <p:txBody>
+          <a:bodyPr/>
+          <a:p/>
+        </p:txBody>
+      </p:sp>
+      <p:sp>
+        <p:nvSpPr>
+          <p:cNvPr id="13" name="Text 11"/>
+          <p:cNvSpPr/>
+          <p:nvPr/>
+        </p:nvSpPr>
+        <p:spPr>
+          <a:xfrm>
+            <a:off x="4654296" y="3090672"/>
+            <a:ext cx="777240" cy="777240"/>
+          </a:xfrm>
+          <a:prstGeom prst="rect">
+            <a:avLst/>
+          </a:prstGeom>
+          <a:noFill/>
+          <a:ln/>
+        </p:spPr>
+        <p:txBody>
+          <a:bodyPr wrap="square" lIns="0" tIns="0" rIns="0" bIns="0" rtlCol="0" anchor="ctr"/>
+          <a:lstStyle/>
+          <a:p>
+            <a:pPr algn="ctr" indent="0" marL="0">
+              <a:buNone/>
+            </a:pPr>
+            <a:r>
+              <a:rPr lang="en-US" sz="3000" b="1" dirty="0">
+                <a:solidFill>
+                  <a:srgbClr val="FFFFFF"/>
+                </a:solidFill>
+                <a:latin typeface="Calibri" pitchFamily="34" charset="0"/>
+                <a:ea typeface="Calibri" pitchFamily="34" charset="-122"/>
+                <a:cs typeface="Calibri" pitchFamily="34" charset="-120"/>
+              </a:rPr>
+              <a:t>2</a:t>
+            </a:r>
+            <a:endParaRPr lang="en-US" sz="3000" dirty="0"/>
+          </a:p>
+        </p:txBody>
+      </p:sp>
+      <p:sp>
+        <p:nvSpPr>
+          <p:cNvPr id="14" name="Text 12"/>
+          <p:cNvSpPr/>
+          <p:nvPr/>
+        </p:nvSpPr>
+        <p:spPr>
+          <a:xfrm>
+            <a:off x="5568696" y="3154680"/>
+            <a:ext cx="1920240" cy="320040"/>
+          </a:xfrm>
+          <a:prstGeom prst="rect">
+            <a:avLst/>
+          </a:prstGeom>
+          <a:noFill/>
+          <a:ln/>
+        </p:spPr>
+        <p:txBody>
+          <a:bodyPr wrap="square" lIns="0" tIns="0" rIns="0" bIns="0" rtlCol="0" anchor="ctr"/>
+          <a:lstStyle/>
+          <a:p>
+            <a:pPr indent="0" marL="0">
+              <a:buNone/>
+            </a:pPr>
+            <a:r>
+              <a:rPr lang="en-US" sz="1100" b="1" spc="100" kern="0" dirty="0">
+                <a:solidFill>
+                  <a:srgbClr val="68786F"/>
+                </a:solidFill>
+                <a:latin typeface="Calibri" pitchFamily="34" charset="0"/>
+                <a:ea typeface="Calibri" pitchFamily="34" charset="-122"/>
+                <a:cs typeface="Calibri" pitchFamily="34" charset="-120"/>
+              </a:rPr>
+              <a:t>Unlock 1</a:t>
+            </a:r>
+            <a:endParaRPr lang="en-US" sz="1100" dirty="0"/>
+          </a:p>
+        </p:txBody>
+      </p:sp>
+      <p:sp>
+        <p:nvSpPr>
+          <p:cNvPr id="15" name="Text 13"/>
+          <p:cNvSpPr/>
+          <p:nvPr/>
+        </p:nvSpPr>
+        <p:spPr>
+          <a:xfrm>
+            <a:off x="5568696" y="3429000"/>
+            <a:ext cx="1920240" cy="457200"/>
+          </a:xfrm>
+          <a:prstGeom prst="rect">
+            <a:avLst/>
+          </a:prstGeom>
+          <a:noFill/>
+          <a:ln/>
+        </p:spPr>
+        <p:txBody>
+          <a:bodyPr wrap="square" lIns="0" tIns="0" rIns="0" bIns="0" rtlCol="0" anchor="ctr"/>
+          <a:lstStyle/>
+          <a:p>
+            <a:pPr indent="0" marL="0">
+              <a:buNone/>
+            </a:pPr>
+            <a:r>
+              <a:rPr lang="en-US" sz="1550" b="1" dirty="0">
+                <a:solidFill>
+                  <a:srgbClr val="123024"/>
+                </a:solidFill>
+                <a:latin typeface="Calibri" pitchFamily="34" charset="0"/>
+                <a:ea typeface="Calibri" pitchFamily="34" charset="-122"/>
+                <a:cs typeface="Calibri" pitchFamily="34" charset="-120"/>
+              </a:rPr>
+              <a:t>Texts become orders</a:t>
+            </a:r>
+            <a:endParaRPr lang="en-US" sz="1550" dirty="0"/>
+          </a:p>
+        </p:txBody>
+      </p:sp>
+      <p:sp>
+        <p:nvSpPr>
+          <p:cNvPr id="16" name="Text 14"/>
+          <p:cNvSpPr/>
+          <p:nvPr/>
+        </p:nvSpPr>
+        <p:spPr>
+          <a:xfrm>
+            <a:off x="4654296" y="4251960"/>
+            <a:ext cx="2743200" cy="1280160"/>
+          </a:xfrm>
+          <a:prstGeom prst="rect">
+            <a:avLst/>
+          </a:prstGeom>
+          <a:noFill/>
+          <a:ln/>
+        </p:spPr>
+        <p:txBody>
+          <a:bodyPr wrap="square" lIns="0" tIns="0" rIns="0" bIns="0" rtlCol="0" anchor="ctr"/>
+          <a:lstStyle/>
+          <a:p>
+            <a:pPr indent="0" marL="0">
+              <a:lnSpc>
+                <a:spcPct val="118000"/>
+              </a:lnSpc>
+              <a:buNone/>
+            </a:pPr>
+            <a:r>
+              <a:rPr lang="en-US" sz="1280" dirty="0">
+                <a:solidFill>
+                  <a:srgbClr val="68786F"/>
+                </a:solidFill>
+                <a:latin typeface="Calibri" pitchFamily="34" charset="0"/>
+                <a:ea typeface="Calibri" pitchFamily="34" charset="-122"/>
+                <a:cs typeface="Calibri" pitchFamily="34" charset="-120"/>
+              </a:rPr>
+              <a:t>AI turns the messy back-and-forth of texts into clean, structured orders — like an Uber Eats ticket. Chefs stop typing into systems.</a:t>
+            </a:r>
+            <a:endParaRPr lang="en-US" sz="1280" dirty="0"/>
+          </a:p>
+        </p:txBody>
+      </p:sp>
+      <p:sp>
+        <p:nvSpPr>
+          <p:cNvPr id="17" name="Shape 15"/>
+          <p:cNvSpPr/>
+          <p:nvPr/>
+        </p:nvSpPr>
+        <p:spPr>
+          <a:xfrm>
+            <a:off x="8010144" y="2743200"/>
+            <a:ext cx="3383280" cy="3017520"/>
+          </a:xfrm>
+          <a:prstGeom prst="roundRect">
+            <a:avLst>
+              <a:gd name="adj" fmla="val 4242"/>
+            </a:avLst>
+          </a:prstGeom>
+          <a:solidFill>
+            <a:srgbClr val="FFFFFF"/>
+          </a:solidFill>
+          <a:ln/>
+          <a:effectLst>
+            <a:outerShdw sx="100000" sy="100000" kx="0" ky="0" algn="bl" rotWithShape="0" blurRad="127000" dist="38100" dir="5400000">
+              <a:srgbClr val="1B3A2E">
+                <a:alpha val="16000"/>
+              </a:srgbClr>
+            </a:outerShdw>
+          </a:effectLst>
+        </p:spPr>
+        <p:txBody>
+          <a:bodyPr/>
+          <a:p/>
+        </p:txBody>
+      </p:sp>
+      <p:sp>
+        <p:nvSpPr>
+          <p:cNvPr id="18" name="Shape 16"/>
+          <p:cNvSpPr/>
+          <p:nvPr/>
+        </p:nvSpPr>
+        <p:spPr>
+          <a:xfrm>
+            <a:off x="8330184" y="3090672"/>
+            <a:ext cx="777240" cy="777240"/>
+          </a:xfrm>
+          <a:prstGeom prst="ellipse">
+            <a:avLst/>
+          </a:prstGeom>
+          <a:solidFill>
+            <a:srgbClr val="4CC499"/>
+          </a:solidFill>
+          <a:ln/>
+        </p:spPr>
+        <p:txBody>
+          <a:bodyPr/>
+          <a:p/>
+        </p:txBody>
+      </p:sp>
+      <p:sp>
+        <p:nvSpPr>
+          <p:cNvPr id="19" name="Text 17"/>
+          <p:cNvSpPr/>
+          <p:nvPr/>
+        </p:nvSpPr>
+        <p:spPr>
+          <a:xfrm>
+            <a:off x="8330184" y="3090672"/>
+            <a:ext cx="777240" cy="777240"/>
+          </a:xfrm>
+          <a:prstGeom prst="rect">
+            <a:avLst/>
+          </a:prstGeom>
+          <a:noFill/>
+          <a:ln/>
+        </p:spPr>
+        <p:txBody>
+          <a:bodyPr wrap="square" lIns="0" tIns="0" rIns="0" bIns="0" rtlCol="0" anchor="ctr"/>
+          <a:lstStyle/>
+          <a:p>
+            <a:pPr algn="ctr" indent="0" marL="0">
+              <a:buNone/>
+            </a:pPr>
+            <a:r>
+              <a:rPr lang="en-US" sz="3000" b="1" dirty="0">
+                <a:solidFill>
+                  <a:srgbClr val="FFFFFF"/>
+                </a:solidFill>
+                <a:latin typeface="Calibri" pitchFamily="34" charset="0"/>
+                <a:ea typeface="Calibri" pitchFamily="34" charset="-122"/>
+                <a:cs typeface="Calibri" pitchFamily="34" charset="-120"/>
+              </a:rPr>
+              <a:t>3</a:t>
+            </a:r>
+            <a:endParaRPr lang="en-US" sz="3000" dirty="0"/>
+          </a:p>
+        </p:txBody>
+      </p:sp>
+      <p:sp>
+        <p:nvSpPr>
+          <p:cNvPr id="20" name="Text 18"/>
+          <p:cNvSpPr/>
+          <p:nvPr/>
+        </p:nvSpPr>
+        <p:spPr>
+          <a:xfrm>
+            <a:off x="9244584" y="3154680"/>
+            <a:ext cx="1920240" cy="320040"/>
+          </a:xfrm>
+          <a:prstGeom prst="rect">
+            <a:avLst/>
+          </a:prstGeom>
+          <a:noFill/>
+          <a:ln/>
+        </p:spPr>
+        <p:txBody>
+          <a:bodyPr wrap="square" lIns="0" tIns="0" rIns="0" bIns="0" rtlCol="0" anchor="ctr"/>
+          <a:lstStyle/>
+          <a:p>
+            <a:pPr indent="0" marL="0">
+              <a:buNone/>
+            </a:pPr>
+            <a:r>
+              <a:rPr lang="en-US" sz="1100" b="1" spc="100" kern="0" dirty="0">
+                <a:solidFill>
+                  <a:srgbClr val="68786F"/>
+                </a:solidFill>
+                <a:latin typeface="Calibri" pitchFamily="34" charset="0"/>
+                <a:ea typeface="Calibri" pitchFamily="34" charset="-122"/>
+                <a:cs typeface="Calibri" pitchFamily="34" charset="-120"/>
+              </a:rPr>
+              <a:t>Unlock 2</a:t>
+            </a:r>
+            <a:endParaRPr lang="en-US" sz="1100" dirty="0"/>
+          </a:p>
+        </p:txBody>
+      </p:sp>
+      <p:sp>
+        <p:nvSpPr>
+          <p:cNvPr id="21" name="Text 19"/>
+          <p:cNvSpPr/>
+          <p:nvPr/>
+        </p:nvSpPr>
+        <p:spPr>
+          <a:xfrm>
+            <a:off x="9244584" y="3429000"/>
+            <a:ext cx="1920240" cy="457200"/>
+          </a:xfrm>
+          <a:prstGeom prst="rect">
+            <a:avLst/>
+          </a:prstGeom>
+          <a:noFill/>
+          <a:ln/>
+        </p:spPr>
+        <p:txBody>
+          <a:bodyPr wrap="square" lIns="0" tIns="0" rIns="0" bIns="0" rtlCol="0" anchor="ctr"/>
+          <a:lstStyle/>
+          <a:p>
+            <a:pPr indent="0" marL="0">
+              <a:buNone/>
+            </a:pPr>
+            <a:r>
+              <a:rPr lang="en-US" sz="1550" b="1" dirty="0">
+                <a:solidFill>
+                  <a:srgbClr val="123024"/>
+                </a:solidFill>
+                <a:latin typeface="Calibri" pitchFamily="34" charset="0"/>
+                <a:ea typeface="Calibri" pitchFamily="34" charset="-122"/>
+                <a:cs typeface="Calibri" pitchFamily="34" charset="-120"/>
+              </a:rPr>
+              <a:t>AI runs the last mile</a:t>
+            </a:r>
+            <a:endParaRPr lang="en-US" sz="1550" dirty="0"/>
+          </a:p>
+        </p:txBody>
+      </p:sp>
+      <p:sp>
+        <p:nvSpPr>
+          <p:cNvPr id="22" name="Text 20"/>
+          <p:cNvSpPr/>
+          <p:nvPr/>
+        </p:nvSpPr>
+        <p:spPr>
+          <a:xfrm>
+            <a:off x="8330184" y="4251960"/>
+            <a:ext cx="2743200" cy="1280160"/>
+          </a:xfrm>
+          <a:prstGeom prst="rect">
+            <a:avLst/>
+          </a:prstGeom>
+          <a:noFill/>
+          <a:ln/>
+        </p:spPr>
+        <p:txBody>
+          <a:bodyPr wrap="square" lIns="0" tIns="0" rIns="0" bIns="0" rtlCol="0" anchor="ctr"/>
+          <a:lstStyle/>
+          <a:p>
+            <a:pPr indent="0" marL="0">
+              <a:lnSpc>
+                <a:spcPct val="118000"/>
+              </a:lnSpc>
+              <a:buNone/>
+            </a:pPr>
+            <a:r>
+              <a:rPr lang="en-US" sz="1280" dirty="0">
+                <a:solidFill>
+                  <a:srgbClr val="68786F"/>
+                </a:solidFill>
+                <a:latin typeface="Calibri" pitchFamily="34" charset="0"/>
+                <a:ea typeface="Calibri" pitchFamily="34" charset="-122"/>
+                <a:cs typeface="Calibri" pitchFamily="34" charset="-120"/>
+              </a:rPr>
+              <a:t>AI coordinates delivery — the exact edge that was the wholesaler's moat. Zero-CapEx: no fleet, no depots.</a:t>
+            </a:r>
+            <a:endParaRPr lang="en-US" sz="1280" dirty="0"/>
+          </a:p>
+        </p:txBody>
+      </p:sp>
+      <p:sp>
+        <p:nvSpPr>
+          <p:cNvPr id="23" name="Text 21"/>
+          <p:cNvSpPr/>
+          <p:nvPr/>
+        </p:nvSpPr>
+        <p:spPr>
+          <a:xfrm>
+            <a:off x="11183112" y="6355080"/>
+            <a:ext cx="548640" cy="274320"/>
+          </a:xfrm>
+          <a:prstGeom prst="rect">
+            <a:avLst/>
+          </a:prstGeom>
+          <a:noFill/>
+          <a:ln/>
+        </p:spPr>
+        <p:txBody>
+          <a:bodyPr wrap="square" lIns="0" tIns="0" rIns="0" bIns="0" rtlCol="0" anchor="ctr"/>
+          <a:lstStyle/>
+          <a:p>
+            <a:pPr algn="r" indent="0" marL="0">
+              <a:buNone/>
+            </a:pPr>
+            <a:r>
+              <a:rPr lang="en-US" sz="1000" dirty="0">
+                <a:solidFill>
+                  <a:srgbClr val="68786F"/>
+                </a:solidFill>
+                <a:latin typeface="Calibri" pitchFamily="34" charset="0"/>
+                <a:ea typeface="Calibri" pitchFamily="34" charset="-122"/>
+                <a:cs typeface="Calibri" pitchFamily="34" charset="-120"/>
+              </a:rPr>
+              <a:t>08</a:t>
+            </a:r>
+            <a:endParaRPr lang="en-US" sz="1000" dirty="0"/>
+          </a:p>
+        </p:txBody>
+      </p:sp>
+      <p:sp>
+        <p:nvSpPr>
+          <p:cNvPr id="24" name="Text 22"/>
+          <p:cNvSpPr/>
+          <p:nvPr/>
+        </p:nvSpPr>
+        <p:spPr>
+          <a:xfrm>
+            <a:off x="658368" y="6355080"/>
+            <a:ext cx="2743200" cy="274320"/>
+          </a:xfrm>
+          <a:prstGeom prst="rect">
+            <a:avLst/>
+          </a:prstGeom>
+          <a:noFill/>
+          <a:ln/>
+        </p:spPr>
+        <p:txBody>
+          <a:bodyPr wrap="square" lIns="0" tIns="0" rIns="0" bIns="0" rtlCol="0" anchor="ctr"/>
+          <a:lstStyle/>
+          <a:p>
+            <a:pPr indent="0" marL="0">
+              <a:buNone/>
+            </a:pPr>
+            <a:r>
+              <a:rPr lang="en-US" sz="1000" b="1" dirty="0">
+                <a:solidFill>
+                  <a:srgbClr val="68786F"/>
+                </a:solidFill>
+                <a:latin typeface="Calibri" pitchFamily="34" charset="0"/>
+                <a:ea typeface="Calibri" pitchFamily="34" charset="-122"/>
+                <a:cs typeface="Calibri" pitchFamily="34" charset="-120"/>
+              </a:rPr>
+              <a:t>Agripals</a:t>
+            </a:r>
+            <a:endParaRPr lang="en-US" sz="1000" dirty="0"/>
+          </a:p>
+        </p:txBody>
+      </p:sp>
+    </p:spTree>
+  </p:cSld>
+  <p:clrMapOvr>
+    <a:masterClrMapping/>
+  </p:clrMapOvr>
+</p:sld>
+</file>
+
+<file path=ppt/slides/slide9.xml><?xml version="1.0" encoding="utf-8"?>
+<p:sld xmlns:a="http://schemas.openxmlformats.org/drawingml/2006/main" xmlns:r="http://schemas.openxmlformats.org/officeDocument/2006/relationships" xmlns:p="http://schemas.openxmlformats.org/presentationml/2006/main">
   <p:cSld name="Slide 8">
     <p:bg>
       <p:bgPr>
@@ -10611,6 +12378,10 @@
             </a:outerShdw>
           </a:effectLst>
         </p:spPr>
+        <p:txBody>
+          <a:bodyPr/>
+          <a:p/>
+        </p:txBody>
       </p:sp>
       <p:sp>
         <p:nvSpPr>
@@ -10631,6 +12402,10 @@
           </a:solidFill>
           <a:ln/>
         </p:spPr>
+        <p:txBody>
+          <a:bodyPr/>
+          <a:p/>
+        </p:txBody>
       </p:sp>
       <p:pic>
         <p:nvPicPr>
@@ -10765,6 +12540,10 @@
             </a:outerShdw>
           </a:effectLst>
         </p:spPr>
+        <p:txBody>
+          <a:bodyPr/>
+          <a:p/>
+        </p:txBody>
       </p:sp>
       <p:sp>
         <p:nvSpPr>
@@ -10785,6 +12564,10 @@
           </a:solidFill>
           <a:ln/>
         </p:spPr>
+        <p:txBody>
+          <a:bodyPr/>
+          <a:p/>
+        </p:txBody>
       </p:sp>
       <p:pic>
         <p:nvPicPr>
@@ -10919,6 +12702,10 @@
             </a:outerShdw>
           </a:effectLst>
         </p:spPr>
+        <p:txBody>
+          <a:bodyPr/>
+          <a:p/>
+        </p:txBody>
       </p:sp>
       <p:sp>
         <p:nvSpPr>
@@ -10939,6 +12726,10 @@
           </a:solidFill>
           <a:ln/>
         </p:spPr>
+        <p:txBody>
+          <a:bodyPr/>
+          <a:p/>
+        </p:txBody>
       </p:sp>
       <p:pic>
         <p:nvPicPr>
@@ -11078,7 +12869,7 @@
                 <a:ea typeface="Calibri" pitchFamily="34" charset="-122"/>
                 <a:cs typeface="Calibri" pitchFamily="34" charset="-120"/>
               </a:rPr>
-              <a:t>08</a:t>
+              <a:t>09</a:t>
             </a:r>
             <a:endParaRPr lang="en-US" sz="1000" dirty="0"/>
           </a:p>
@@ -11087,863 +12878,6 @@
       <p:sp>
         <p:nvSpPr>
           <p:cNvPr id="20" name="Text 15"/>
-          <p:cNvSpPr/>
-          <p:nvPr/>
-        </p:nvSpPr>
-        <p:spPr>
-          <a:xfrm>
-            <a:off x="658368" y="6355080"/>
-            <a:ext cx="2743200" cy="274320"/>
-          </a:xfrm>
-          <a:prstGeom prst="rect">
-            <a:avLst/>
-          </a:prstGeom>
-          <a:noFill/>
-          <a:ln/>
-        </p:spPr>
-        <p:txBody>
-          <a:bodyPr wrap="square" lIns="0" tIns="0" rIns="0" bIns="0" rtlCol="0" anchor="ctr"/>
-          <a:lstStyle/>
-          <a:p>
-            <a:pPr indent="0" marL="0">
-              <a:buNone/>
-            </a:pPr>
-            <a:r>
-              <a:rPr lang="en-US" sz="1000" b="1" dirty="0">
-                <a:solidFill>
-                  <a:srgbClr val="68786F"/>
-                </a:solidFill>
-                <a:latin typeface="Calibri" pitchFamily="34" charset="0"/>
-                <a:ea typeface="Calibri" pitchFamily="34" charset="-122"/>
-                <a:cs typeface="Calibri" pitchFamily="34" charset="-120"/>
-              </a:rPr>
-              <a:t>Agripals</a:t>
-            </a:r>
-            <a:endParaRPr lang="en-US" sz="1000" dirty="0"/>
-          </a:p>
-        </p:txBody>
-      </p:sp>
-    </p:spTree>
-  </p:cSld>
-  <p:clrMapOvr>
-    <a:masterClrMapping/>
-  </p:clrMapOvr>
-</p:sld>
-</file>
-
-<file path=ppt/slides/slide9.xml><?xml version="1.0" encoding="utf-8"?>
-<p:sld xmlns:a="http://schemas.openxmlformats.org/drawingml/2006/main" xmlns:r="http://schemas.openxmlformats.org/officeDocument/2006/relationships" xmlns:p="http://schemas.openxmlformats.org/presentationml/2006/main">
-  <p:cSld name="Slide 9">
-    <p:bg>
-      <p:bgPr>
-        <a:solidFill>
-          <a:srgbClr val="F4F7F6"/>
-        </a:solidFill>
-      </p:bgPr>
-    </p:bg>
-    <p:spTree>
-      <p:nvGrpSpPr>
-        <p:cNvPr id="1" name=""/>
-        <p:cNvGrpSpPr/>
-        <p:nvPr/>
-      </p:nvGrpSpPr>
-      <p:grpSpPr>
-        <a:xfrm>
-          <a:off x="0" y="0"/>
-          <a:ext cx="0" cy="0"/>
-          <a:chOff x="0" y="0"/>
-          <a:chExt cx="0" cy="0"/>
-        </a:xfrm>
-      </p:grpSpPr>
-      <p:sp>
-        <p:nvSpPr>
-          <p:cNvPr id="2" name="Text 0"/>
-          <p:cNvSpPr/>
-          <p:nvPr/>
-        </p:nvSpPr>
-        <p:spPr>
-          <a:xfrm>
-            <a:off x="658368" y="457200"/>
-            <a:ext cx="8229600" cy="320040"/>
-          </a:xfrm>
-          <a:prstGeom prst="rect">
-            <a:avLst/>
-          </a:prstGeom>
-          <a:noFill/>
-          <a:ln/>
-        </p:spPr>
-        <p:txBody>
-          <a:bodyPr wrap="square" lIns="0" tIns="0" rIns="0" bIns="0" rtlCol="0" anchor="ctr"/>
-          <a:lstStyle/>
-          <a:p>
-            <a:pPr algn="l" indent="0" marL="0">
-              <a:buNone/>
-            </a:pPr>
-            <a:r>
-              <a:rPr lang="en-US" sz="1250" b="1" spc="300" kern="0" dirty="0">
-                <a:solidFill>
-                  <a:srgbClr val="37A278"/>
-                </a:solidFill>
-                <a:latin typeface="Calibri" pitchFamily="34" charset="0"/>
-                <a:ea typeface="Calibri" pitchFamily="34" charset="-122"/>
-                <a:cs typeface="Calibri" pitchFamily="34" charset="-120"/>
-              </a:rPr>
-              <a:t>GO TO MARKET</a:t>
-            </a:r>
-            <a:endParaRPr lang="en-US" sz="1250" dirty="0"/>
-          </a:p>
-        </p:txBody>
-      </p:sp>
-      <p:sp>
-        <p:nvSpPr>
-          <p:cNvPr id="3" name="Text 1"/>
-          <p:cNvSpPr/>
-          <p:nvPr/>
-        </p:nvSpPr>
-        <p:spPr>
-          <a:xfrm>
-            <a:off x="658368" y="841248"/>
-            <a:ext cx="10872216" cy="1051560"/>
-          </a:xfrm>
-          <a:prstGeom prst="rect">
-            <a:avLst/>
-          </a:prstGeom>
-          <a:noFill/>
-          <a:ln/>
-        </p:spPr>
-        <p:txBody>
-          <a:bodyPr wrap="square" lIns="0" tIns="0" rIns="0" bIns="0" rtlCol="0" anchor="ctr"/>
-          <a:lstStyle/>
-          <a:p>
-            <a:pPr algn="l" indent="0" marL="0">
-              <a:lnSpc>
-                <a:spcPct val="100000"/>
-              </a:lnSpc>
-              <a:buNone/>
-            </a:pPr>
-            <a:r>
-              <a:rPr lang="en-US" sz="3400" b="1" dirty="0">
-                <a:solidFill>
-                  <a:srgbClr val="123024"/>
-                </a:solidFill>
-                <a:latin typeface="Calibri" pitchFamily="34" charset="0"/>
-                <a:ea typeface="Calibri" pitchFamily="34" charset="-122"/>
-                <a:cs typeface="Calibri" pitchFamily="34" charset="-120"/>
-              </a:rPr>
-              <a:t>One city. One product. One clear proof point.</a:t>
-            </a:r>
-            <a:endParaRPr lang="en-US" sz="3400" dirty="0"/>
-          </a:p>
-        </p:txBody>
-      </p:sp>
-      <p:sp>
-        <p:nvSpPr>
-          <p:cNvPr id="4" name="Text 2"/>
-          <p:cNvSpPr/>
-          <p:nvPr/>
-        </p:nvSpPr>
-        <p:spPr>
-          <a:xfrm>
-            <a:off x="658368" y="1828800"/>
-            <a:ext cx="10607040" cy="640080"/>
-          </a:xfrm>
-          <a:prstGeom prst="rect">
-            <a:avLst/>
-          </a:prstGeom>
-          <a:noFill/>
-          <a:ln/>
-        </p:spPr>
-        <p:txBody>
-          <a:bodyPr wrap="square" lIns="0" tIns="0" rIns="0" bIns="0" rtlCol="0" anchor="ctr"/>
-          <a:lstStyle/>
-          <a:p>
-            <a:pPr indent="0" marL="0">
-              <a:lnSpc>
-                <a:spcPct val="115000"/>
-              </a:lnSpc>
-              <a:buNone/>
-            </a:pPr>
-            <a:r>
-              <a:rPr lang="en-US" sz="1600" dirty="0">
-                <a:solidFill>
-                  <a:srgbClr val="12201A"/>
-                </a:solidFill>
-                <a:latin typeface="Calibri" pitchFamily="34" charset="0"/>
-                <a:ea typeface="Calibri" pitchFamily="34" charset="-122"/>
-                <a:cs typeface="Calibri" pitchFamily="34" charset="-120"/>
-              </a:rPr>
-              <a:t>San Francisco oysters — direct from Northern California farms into SF restaurants — then expand the same rails outward.</a:t>
-            </a:r>
-            <a:endParaRPr lang="en-US" sz="1600" dirty="0"/>
-          </a:p>
-        </p:txBody>
-      </p:sp>
-      <p:sp>
-        <p:nvSpPr>
-          <p:cNvPr id="5" name="Shape 3"/>
-          <p:cNvSpPr/>
-          <p:nvPr/>
-        </p:nvSpPr>
-        <p:spPr>
-          <a:xfrm>
-            <a:off x="658368" y="2743200"/>
-            <a:ext cx="3383280" cy="3017520"/>
-          </a:xfrm>
-          <a:prstGeom prst="roundRect">
-            <a:avLst>
-              <a:gd name="adj" fmla="val 4242"/>
-            </a:avLst>
-          </a:prstGeom>
-          <a:solidFill>
-            <a:srgbClr val="FFFFFF"/>
-          </a:solidFill>
-          <a:ln/>
-          <a:effectLst>
-            <a:outerShdw sx="100000" sy="100000" kx="0" ky="0" algn="bl" rotWithShape="0" blurRad="127000" dist="38100" dir="5400000">
-              <a:srgbClr val="1B3A2E">
-                <a:alpha val="16000"/>
-              </a:srgbClr>
-            </a:outerShdw>
-          </a:effectLst>
-        </p:spPr>
-      </p:sp>
-      <p:sp>
-        <p:nvSpPr>
-          <p:cNvPr id="6" name="Shape 4"/>
-          <p:cNvSpPr/>
-          <p:nvPr/>
-        </p:nvSpPr>
-        <p:spPr>
-          <a:xfrm>
-            <a:off x="978408" y="3090672"/>
-            <a:ext cx="777240" cy="777240"/>
-          </a:xfrm>
-          <a:prstGeom prst="ellipse">
-            <a:avLst/>
-          </a:prstGeom>
-          <a:solidFill>
-            <a:srgbClr val="2E8564"/>
-          </a:solidFill>
-          <a:ln/>
-        </p:spPr>
-      </p:sp>
-      <p:sp>
-        <p:nvSpPr>
-          <p:cNvPr id="7" name="Text 5"/>
-          <p:cNvSpPr/>
-          <p:nvPr/>
-        </p:nvSpPr>
-        <p:spPr>
-          <a:xfrm>
-            <a:off x="978408" y="3090672"/>
-            <a:ext cx="777240" cy="777240"/>
-          </a:xfrm>
-          <a:prstGeom prst="rect">
-            <a:avLst/>
-          </a:prstGeom>
-          <a:noFill/>
-          <a:ln/>
-        </p:spPr>
-        <p:txBody>
-          <a:bodyPr wrap="square" lIns="0" tIns="0" rIns="0" bIns="0" rtlCol="0" anchor="ctr"/>
-          <a:lstStyle/>
-          <a:p>
-            <a:pPr algn="ctr" indent="0" marL="0">
-              <a:buNone/>
-            </a:pPr>
-            <a:r>
-              <a:rPr lang="en-US" sz="3000" b="1" dirty="0">
-                <a:solidFill>
-                  <a:srgbClr val="FFFFFF"/>
-                </a:solidFill>
-                <a:latin typeface="Calibri" pitchFamily="34" charset="0"/>
-                <a:ea typeface="Calibri" pitchFamily="34" charset="-122"/>
-                <a:cs typeface="Calibri" pitchFamily="34" charset="-120"/>
-              </a:rPr>
-              <a:t>1</a:t>
-            </a:r>
-            <a:endParaRPr lang="en-US" sz="3000" dirty="0"/>
-          </a:p>
-        </p:txBody>
-      </p:sp>
-      <p:sp>
-        <p:nvSpPr>
-          <p:cNvPr id="8" name="Text 6"/>
-          <p:cNvSpPr/>
-          <p:nvPr/>
-        </p:nvSpPr>
-        <p:spPr>
-          <a:xfrm>
-            <a:off x="1892808" y="3154680"/>
-            <a:ext cx="1920240" cy="320040"/>
-          </a:xfrm>
-          <a:prstGeom prst="rect">
-            <a:avLst/>
-          </a:prstGeom>
-          <a:noFill/>
-          <a:ln/>
-        </p:spPr>
-        <p:txBody>
-          <a:bodyPr wrap="square" lIns="0" tIns="0" rIns="0" bIns="0" rtlCol="0" anchor="ctr"/>
-          <a:lstStyle/>
-          <a:p>
-            <a:pPr indent="0" marL="0">
-              <a:buNone/>
-            </a:pPr>
-            <a:r>
-              <a:rPr lang="en-US" sz="1100" b="1" spc="100" kern="0" dirty="0">
-                <a:solidFill>
-                  <a:srgbClr val="68786F"/>
-                </a:solidFill>
-                <a:latin typeface="Calibri" pitchFamily="34" charset="0"/>
-                <a:ea typeface="Calibri" pitchFamily="34" charset="-122"/>
-                <a:cs typeface="Calibri" pitchFamily="34" charset="-120"/>
-              </a:rPr>
-              <a:t>Phase 1</a:t>
-            </a:r>
-            <a:endParaRPr lang="en-US" sz="1100" dirty="0"/>
-          </a:p>
-        </p:txBody>
-      </p:sp>
-      <p:sp>
-        <p:nvSpPr>
-          <p:cNvPr id="9" name="Text 7"/>
-          <p:cNvSpPr/>
-          <p:nvPr/>
-        </p:nvSpPr>
-        <p:spPr>
-          <a:xfrm>
-            <a:off x="1892808" y="3429000"/>
-            <a:ext cx="1920240" cy="457200"/>
-          </a:xfrm>
-          <a:prstGeom prst="rect">
-            <a:avLst/>
-          </a:prstGeom>
-          <a:noFill/>
-          <a:ln/>
-        </p:spPr>
-        <p:txBody>
-          <a:bodyPr wrap="square" lIns="0" tIns="0" rIns="0" bIns="0" rtlCol="0" anchor="ctr"/>
-          <a:lstStyle/>
-          <a:p>
-            <a:pPr indent="0" marL="0">
-              <a:buNone/>
-            </a:pPr>
-            <a:r>
-              <a:rPr lang="en-US" sz="1550" b="1" dirty="0">
-                <a:solidFill>
-                  <a:srgbClr val="123024"/>
-                </a:solidFill>
-                <a:latin typeface="Calibri" pitchFamily="34" charset="0"/>
-                <a:ea typeface="Calibri" pitchFamily="34" charset="-122"/>
-                <a:cs typeface="Calibri" pitchFamily="34" charset="-120"/>
-              </a:rPr>
-              <a:t>SF oysters</a:t>
-            </a:r>
-            <a:endParaRPr lang="en-US" sz="1550" dirty="0"/>
-          </a:p>
-        </p:txBody>
-      </p:sp>
-      <p:sp>
-        <p:nvSpPr>
-          <p:cNvPr id="10" name="Text 8"/>
-          <p:cNvSpPr/>
-          <p:nvPr/>
-        </p:nvSpPr>
-        <p:spPr>
-          <a:xfrm>
-            <a:off x="978408" y="4251960"/>
-            <a:ext cx="2743200" cy="1280160"/>
-          </a:xfrm>
-          <a:prstGeom prst="rect">
-            <a:avLst/>
-          </a:prstGeom>
-          <a:noFill/>
-          <a:ln/>
-        </p:spPr>
-        <p:txBody>
-          <a:bodyPr wrap="square" lIns="0" tIns="0" rIns="0" bIns="0" rtlCol="0" anchor="ctr"/>
-          <a:lstStyle/>
-          <a:p>
-            <a:pPr indent="0" marL="0">
-              <a:lnSpc>
-                <a:spcPct val="118000"/>
-              </a:lnSpc>
-              <a:buNone/>
-            </a:pPr>
-            <a:r>
-              <a:rPr lang="en-US" sz="1280" dirty="0">
-                <a:solidFill>
-                  <a:srgbClr val="68786F"/>
-                </a:solidFill>
-                <a:latin typeface="Calibri" pitchFamily="34" charset="0"/>
-                <a:ea typeface="Calibri" pitchFamily="34" charset="-122"/>
-                <a:cs typeface="Calibri" pitchFamily="34" charset="-120"/>
-              </a:rPr>
-              <a:t>~10 oyster farmers, 10–20 restaurants, one reliable cold-chain logistics partner.</a:t>
-            </a:r>
-            <a:endParaRPr lang="en-US" sz="1280" dirty="0"/>
-          </a:p>
-        </p:txBody>
-      </p:sp>
-      <p:sp>
-        <p:nvSpPr>
-          <p:cNvPr id="11" name="Shape 9"/>
-          <p:cNvSpPr/>
-          <p:nvPr/>
-        </p:nvSpPr>
-        <p:spPr>
-          <a:xfrm>
-            <a:off x="4334256" y="2743200"/>
-            <a:ext cx="3383280" cy="3017520"/>
-          </a:xfrm>
-          <a:prstGeom prst="roundRect">
-            <a:avLst>
-              <a:gd name="adj" fmla="val 4242"/>
-            </a:avLst>
-          </a:prstGeom>
-          <a:solidFill>
-            <a:srgbClr val="FFFFFF"/>
-          </a:solidFill>
-          <a:ln/>
-          <a:effectLst>
-            <a:outerShdw sx="100000" sy="100000" kx="0" ky="0" algn="bl" rotWithShape="0" blurRad="127000" dist="38100" dir="5400000">
-              <a:srgbClr val="1B3A2E">
-                <a:alpha val="16000"/>
-              </a:srgbClr>
-            </a:outerShdw>
-          </a:effectLst>
-        </p:spPr>
-      </p:sp>
-      <p:sp>
-        <p:nvSpPr>
-          <p:cNvPr id="12" name="Shape 10"/>
-          <p:cNvSpPr/>
-          <p:nvPr/>
-        </p:nvSpPr>
-        <p:spPr>
-          <a:xfrm>
-            <a:off x="4654296" y="3090672"/>
-            <a:ext cx="777240" cy="777240"/>
-          </a:xfrm>
-          <a:prstGeom prst="ellipse">
-            <a:avLst/>
-          </a:prstGeom>
-          <a:solidFill>
-            <a:srgbClr val="37A278"/>
-          </a:solidFill>
-          <a:ln/>
-        </p:spPr>
-      </p:sp>
-      <p:sp>
-        <p:nvSpPr>
-          <p:cNvPr id="13" name="Text 11"/>
-          <p:cNvSpPr/>
-          <p:nvPr/>
-        </p:nvSpPr>
-        <p:spPr>
-          <a:xfrm>
-            <a:off x="4654296" y="3090672"/>
-            <a:ext cx="777240" cy="777240"/>
-          </a:xfrm>
-          <a:prstGeom prst="rect">
-            <a:avLst/>
-          </a:prstGeom>
-          <a:noFill/>
-          <a:ln/>
-        </p:spPr>
-        <p:txBody>
-          <a:bodyPr wrap="square" lIns="0" tIns="0" rIns="0" bIns="0" rtlCol="0" anchor="ctr"/>
-          <a:lstStyle/>
-          <a:p>
-            <a:pPr algn="ctr" indent="0" marL="0">
-              <a:buNone/>
-            </a:pPr>
-            <a:r>
-              <a:rPr lang="en-US" sz="3000" b="1" dirty="0">
-                <a:solidFill>
-                  <a:srgbClr val="FFFFFF"/>
-                </a:solidFill>
-                <a:latin typeface="Calibri" pitchFamily="34" charset="0"/>
-                <a:ea typeface="Calibri" pitchFamily="34" charset="-122"/>
-                <a:cs typeface="Calibri" pitchFamily="34" charset="-120"/>
-              </a:rPr>
-              <a:t>2</a:t>
-            </a:r>
-            <a:endParaRPr lang="en-US" sz="3000" dirty="0"/>
-          </a:p>
-        </p:txBody>
-      </p:sp>
-      <p:sp>
-        <p:nvSpPr>
-          <p:cNvPr id="14" name="Text 12"/>
-          <p:cNvSpPr/>
-          <p:nvPr/>
-        </p:nvSpPr>
-        <p:spPr>
-          <a:xfrm>
-            <a:off x="5568696" y="3154680"/>
-            <a:ext cx="1920240" cy="320040"/>
-          </a:xfrm>
-          <a:prstGeom prst="rect">
-            <a:avLst/>
-          </a:prstGeom>
-          <a:noFill/>
-          <a:ln/>
-        </p:spPr>
-        <p:txBody>
-          <a:bodyPr wrap="square" lIns="0" tIns="0" rIns="0" bIns="0" rtlCol="0" anchor="ctr"/>
-          <a:lstStyle/>
-          <a:p>
-            <a:pPr indent="0" marL="0">
-              <a:buNone/>
-            </a:pPr>
-            <a:r>
-              <a:rPr lang="en-US" sz="1100" b="1" spc="100" kern="0" dirty="0">
-                <a:solidFill>
-                  <a:srgbClr val="68786F"/>
-                </a:solidFill>
-                <a:latin typeface="Calibri" pitchFamily="34" charset="0"/>
-                <a:ea typeface="Calibri" pitchFamily="34" charset="-122"/>
-                <a:cs typeface="Calibri" pitchFamily="34" charset="-120"/>
-              </a:rPr>
-              <a:t>Phase 2</a:t>
-            </a:r>
-            <a:endParaRPr lang="en-US" sz="1100" dirty="0"/>
-          </a:p>
-        </p:txBody>
-      </p:sp>
-      <p:sp>
-        <p:nvSpPr>
-          <p:cNvPr id="15" name="Text 13"/>
-          <p:cNvSpPr/>
-          <p:nvPr/>
-        </p:nvSpPr>
-        <p:spPr>
-          <a:xfrm>
-            <a:off x="5568696" y="3429000"/>
-            <a:ext cx="1920240" cy="457200"/>
-          </a:xfrm>
-          <a:prstGeom prst="rect">
-            <a:avLst/>
-          </a:prstGeom>
-          <a:noFill/>
-          <a:ln/>
-        </p:spPr>
-        <p:txBody>
-          <a:bodyPr wrap="square" lIns="0" tIns="0" rIns="0" bIns="0" rtlCol="0" anchor="ctr"/>
-          <a:lstStyle/>
-          <a:p>
-            <a:pPr indent="0" marL="0">
-              <a:buNone/>
-            </a:pPr>
-            <a:r>
-              <a:rPr lang="en-US" sz="1550" b="1" dirty="0">
-                <a:solidFill>
-                  <a:srgbClr val="123024"/>
-                </a:solidFill>
-                <a:latin typeface="Calibri" pitchFamily="34" charset="0"/>
-                <a:ea typeface="Calibri" pitchFamily="34" charset="-122"/>
-                <a:cs typeface="Calibri" pitchFamily="34" charset="-120"/>
-              </a:rPr>
-              <a:t>More direct seafood</a:t>
-            </a:r>
-            <a:endParaRPr lang="en-US" sz="1550" dirty="0"/>
-          </a:p>
-        </p:txBody>
-      </p:sp>
-      <p:sp>
-        <p:nvSpPr>
-          <p:cNvPr id="16" name="Text 14"/>
-          <p:cNvSpPr/>
-          <p:nvPr/>
-        </p:nvSpPr>
-        <p:spPr>
-          <a:xfrm>
-            <a:off x="4654296" y="4251960"/>
-            <a:ext cx="2743200" cy="1280160"/>
-          </a:xfrm>
-          <a:prstGeom prst="rect">
-            <a:avLst/>
-          </a:prstGeom>
-          <a:noFill/>
-          <a:ln/>
-        </p:spPr>
-        <p:txBody>
-          <a:bodyPr wrap="square" lIns="0" tIns="0" rIns="0" bIns="0" rtlCol="0" anchor="ctr"/>
-          <a:lstStyle/>
-          <a:p>
-            <a:pPr indent="0" marL="0">
-              <a:lnSpc>
-                <a:spcPct val="118000"/>
-              </a:lnSpc>
-              <a:buNone/>
-            </a:pPr>
-            <a:r>
-              <a:rPr lang="en-US" sz="1280" dirty="0">
-                <a:solidFill>
-                  <a:srgbClr val="68786F"/>
-                </a:solidFill>
-                <a:latin typeface="Calibri" pitchFamily="34" charset="0"/>
-                <a:ea typeface="Calibri" pitchFamily="34" charset="-122"/>
-                <a:cs typeface="Calibri" pitchFamily="34" charset="-120"/>
-              </a:rPr>
-              <a:t>Shrimp, lobster, crab and other gradable products where freshness and provenance matter.</a:t>
-            </a:r>
-            <a:endParaRPr lang="en-US" sz="1280" dirty="0"/>
-          </a:p>
-        </p:txBody>
-      </p:sp>
-      <p:sp>
-        <p:nvSpPr>
-          <p:cNvPr id="17" name="Shape 15"/>
-          <p:cNvSpPr/>
-          <p:nvPr/>
-        </p:nvSpPr>
-        <p:spPr>
-          <a:xfrm>
-            <a:off x="8010144" y="2743200"/>
-            <a:ext cx="3383280" cy="3017520"/>
-          </a:xfrm>
-          <a:prstGeom prst="roundRect">
-            <a:avLst>
-              <a:gd name="adj" fmla="val 4242"/>
-            </a:avLst>
-          </a:prstGeom>
-          <a:solidFill>
-            <a:srgbClr val="FFFFFF"/>
-          </a:solidFill>
-          <a:ln/>
-          <a:effectLst>
-            <a:outerShdw sx="100000" sy="100000" kx="0" ky="0" algn="bl" rotWithShape="0" blurRad="127000" dist="38100" dir="5400000">
-              <a:srgbClr val="1B3A2E">
-                <a:alpha val="16000"/>
-              </a:srgbClr>
-            </a:outerShdw>
-          </a:effectLst>
-        </p:spPr>
-      </p:sp>
-      <p:sp>
-        <p:nvSpPr>
-          <p:cNvPr id="18" name="Shape 16"/>
-          <p:cNvSpPr/>
-          <p:nvPr/>
-        </p:nvSpPr>
-        <p:spPr>
-          <a:xfrm>
-            <a:off x="8330184" y="3090672"/>
-            <a:ext cx="777240" cy="777240"/>
-          </a:xfrm>
-          <a:prstGeom prst="ellipse">
-            <a:avLst/>
-          </a:prstGeom>
-          <a:solidFill>
-            <a:srgbClr val="4CC499"/>
-          </a:solidFill>
-          <a:ln/>
-        </p:spPr>
-      </p:sp>
-      <p:sp>
-        <p:nvSpPr>
-          <p:cNvPr id="19" name="Text 17"/>
-          <p:cNvSpPr/>
-          <p:nvPr/>
-        </p:nvSpPr>
-        <p:spPr>
-          <a:xfrm>
-            <a:off x="8330184" y="3090672"/>
-            <a:ext cx="777240" cy="777240"/>
-          </a:xfrm>
-          <a:prstGeom prst="rect">
-            <a:avLst/>
-          </a:prstGeom>
-          <a:noFill/>
-          <a:ln/>
-        </p:spPr>
-        <p:txBody>
-          <a:bodyPr wrap="square" lIns="0" tIns="0" rIns="0" bIns="0" rtlCol="0" anchor="ctr"/>
-          <a:lstStyle/>
-          <a:p>
-            <a:pPr algn="ctr" indent="0" marL="0">
-              <a:buNone/>
-            </a:pPr>
-            <a:r>
-              <a:rPr lang="en-US" sz="3000" b="1" dirty="0">
-                <a:solidFill>
-                  <a:srgbClr val="FFFFFF"/>
-                </a:solidFill>
-                <a:latin typeface="Calibri" pitchFamily="34" charset="0"/>
-                <a:ea typeface="Calibri" pitchFamily="34" charset="-122"/>
-                <a:cs typeface="Calibri" pitchFamily="34" charset="-120"/>
-              </a:rPr>
-              <a:t>3</a:t>
-            </a:r>
-            <a:endParaRPr lang="en-US" sz="3000" dirty="0"/>
-          </a:p>
-        </p:txBody>
-      </p:sp>
-      <p:sp>
-        <p:nvSpPr>
-          <p:cNvPr id="20" name="Text 18"/>
-          <p:cNvSpPr/>
-          <p:nvPr/>
-        </p:nvSpPr>
-        <p:spPr>
-          <a:xfrm>
-            <a:off x="9244584" y="3154680"/>
-            <a:ext cx="1920240" cy="320040"/>
-          </a:xfrm>
-          <a:prstGeom prst="rect">
-            <a:avLst/>
-          </a:prstGeom>
-          <a:noFill/>
-          <a:ln/>
-        </p:spPr>
-        <p:txBody>
-          <a:bodyPr wrap="square" lIns="0" tIns="0" rIns="0" bIns="0" rtlCol="0" anchor="ctr"/>
-          <a:lstStyle/>
-          <a:p>
-            <a:pPr indent="0" marL="0">
-              <a:buNone/>
-            </a:pPr>
-            <a:r>
-              <a:rPr lang="en-US" sz="1100" b="1" spc="100" kern="0" dirty="0">
-                <a:solidFill>
-                  <a:srgbClr val="68786F"/>
-                </a:solidFill>
-                <a:latin typeface="Calibri" pitchFamily="34" charset="0"/>
-                <a:ea typeface="Calibri" pitchFamily="34" charset="-122"/>
-                <a:cs typeface="Calibri" pitchFamily="34" charset="-120"/>
-              </a:rPr>
-              <a:t>Phase 3</a:t>
-            </a:r>
-            <a:endParaRPr lang="en-US" sz="1100" dirty="0"/>
-          </a:p>
-        </p:txBody>
-      </p:sp>
-      <p:sp>
-        <p:nvSpPr>
-          <p:cNvPr id="21" name="Text 19"/>
-          <p:cNvSpPr/>
-          <p:nvPr/>
-        </p:nvSpPr>
-        <p:spPr>
-          <a:xfrm>
-            <a:off x="9244584" y="3429000"/>
-            <a:ext cx="1920240" cy="457200"/>
-          </a:xfrm>
-          <a:prstGeom prst="rect">
-            <a:avLst/>
-          </a:prstGeom>
-          <a:noFill/>
-          <a:ln/>
-        </p:spPr>
-        <p:txBody>
-          <a:bodyPr wrap="square" lIns="0" tIns="0" rIns="0" bIns="0" rtlCol="0" anchor="ctr"/>
-          <a:lstStyle/>
-          <a:p>
-            <a:pPr indent="0" marL="0">
-              <a:buNone/>
-            </a:pPr>
-            <a:r>
-              <a:rPr lang="en-US" sz="1550" b="1" dirty="0">
-                <a:solidFill>
-                  <a:srgbClr val="123024"/>
-                </a:solidFill>
-                <a:latin typeface="Calibri" pitchFamily="34" charset="0"/>
-                <a:ea typeface="Calibri" pitchFamily="34" charset="-122"/>
-                <a:cs typeface="Calibri" pitchFamily="34" charset="-120"/>
-              </a:rPr>
-              <a:t>Direct import / export</a:t>
-            </a:r>
-            <a:endParaRPr lang="en-US" sz="1550" dirty="0"/>
-          </a:p>
-        </p:txBody>
-      </p:sp>
-      <p:sp>
-        <p:nvSpPr>
-          <p:cNvPr id="22" name="Text 20"/>
-          <p:cNvSpPr/>
-          <p:nvPr/>
-        </p:nvSpPr>
-        <p:spPr>
-          <a:xfrm>
-            <a:off x="8330184" y="4251960"/>
-            <a:ext cx="2743200" cy="1280160"/>
-          </a:xfrm>
-          <a:prstGeom prst="rect">
-            <a:avLst/>
-          </a:prstGeom>
-          <a:noFill/>
-          <a:ln/>
-        </p:spPr>
-        <p:txBody>
-          <a:bodyPr wrap="square" lIns="0" tIns="0" rIns="0" bIns="0" rtlCol="0" anchor="ctr"/>
-          <a:lstStyle/>
-          <a:p>
-            <a:pPr indent="0" marL="0">
-              <a:lnSpc>
-                <a:spcPct val="118000"/>
-              </a:lnSpc>
-              <a:buNone/>
-            </a:pPr>
-            <a:r>
-              <a:rPr lang="en-US" sz="1280" dirty="0">
-                <a:solidFill>
-                  <a:srgbClr val="68786F"/>
-                </a:solidFill>
-                <a:latin typeface="Calibri" pitchFamily="34" charset="0"/>
-                <a:ea typeface="Calibri" pitchFamily="34" charset="-122"/>
-                <a:cs typeface="Calibri" pitchFamily="34" charset="-120"/>
-              </a:rPr>
-              <a:t>Cut exporters and importers too, with AI coordinating documents, routing and compliance.</a:t>
-            </a:r>
-            <a:endParaRPr lang="en-US" sz="1280" dirty="0"/>
-          </a:p>
-        </p:txBody>
-      </p:sp>
-      <p:sp>
-        <p:nvSpPr>
-          <p:cNvPr id="23" name="Text 21"/>
-          <p:cNvSpPr/>
-          <p:nvPr/>
-        </p:nvSpPr>
-        <p:spPr>
-          <a:xfrm>
-            <a:off x="11183112" y="6355080"/>
-            <a:ext cx="548640" cy="274320"/>
-          </a:xfrm>
-          <a:prstGeom prst="rect">
-            <a:avLst/>
-          </a:prstGeom>
-          <a:noFill/>
-          <a:ln/>
-        </p:spPr>
-        <p:txBody>
-          <a:bodyPr wrap="square" lIns="0" tIns="0" rIns="0" bIns="0" rtlCol="0" anchor="ctr"/>
-          <a:lstStyle/>
-          <a:p>
-            <a:pPr algn="r" indent="0" marL="0">
-              <a:buNone/>
-            </a:pPr>
-            <a:r>
-              <a:rPr lang="en-US" sz="1000" dirty="0">
-                <a:solidFill>
-                  <a:srgbClr val="68786F"/>
-                </a:solidFill>
-                <a:latin typeface="Calibri" pitchFamily="34" charset="0"/>
-                <a:ea typeface="Calibri" pitchFamily="34" charset="-122"/>
-                <a:cs typeface="Calibri" pitchFamily="34" charset="-120"/>
-              </a:rPr>
-              <a:t>09</a:t>
-            </a:r>
-            <a:endParaRPr lang="en-US" sz="1000" dirty="0"/>
-          </a:p>
-        </p:txBody>
-      </p:sp>
-      <p:sp>
-        <p:nvSpPr>
-          <p:cNvPr id="24" name="Text 22"/>
           <p:cNvSpPr/>
           <p:nvPr/>
         </p:nvSpPr>

</xml_diff>

<commit_message>
Add Option C.5 (deal-first Agripals): Royal Miyagi deal + mobile CTA as hero, informative header, no form/login; add C.5 to switchers; add second investor deck + market audit
</commit_message>
<xml_diff>
--- a/Agripals-Investor-Deck.pptx
+++ b/Agripals-Investor-Deck.pptx
@@ -24,6 +24,7 @@
     <p:sldId id="268" r:id="rId14"/>
     <p:sldId id="274" r:id="rId25"/>
     <p:sldId id="275" r:id="rId26"/>
+    <p:sldId id="276" r:id="rId27"/>
     <p:sldId id="269" r:id="rId15"/>
   </p:sldIdLst>
   <p:notesMasterIdLst>
@@ -10194,6 +10195,887 @@
 
 <file path=ppt/slides/slide20.xml><?xml version="1.0" encoding="utf-8"?>
 <p:sld xmlns:a="http://schemas.openxmlformats.org/drawingml/2006/main" xmlns:r="http://schemas.openxmlformats.org/officeDocument/2006/relationships" xmlns:p="http://schemas.openxmlformats.org/presentationml/2006/main">
+  <p:cSld name="Slide 9">
+    <p:bg>
+      <p:bgPr>
+        <a:solidFill>
+          <a:srgbClr val="F4F7F6"/>
+        </a:solidFill>
+      </p:bgPr>
+    </p:bg>
+    <p:spTree>
+      <p:nvGrpSpPr>
+        <p:cNvPr id="1" name=""/>
+        <p:cNvGrpSpPr/>
+        <p:nvPr/>
+      </p:nvGrpSpPr>
+      <p:grpSpPr>
+        <a:xfrm>
+          <a:off x="0" y="0"/>
+          <a:ext cx="0" cy="0"/>
+          <a:chOff x="0" y="0"/>
+          <a:chExt cx="0" cy="0"/>
+        </a:xfrm>
+      </p:grpSpPr>
+      <p:sp>
+        <p:nvSpPr>
+          <p:cNvPr id="2" name="Text 0"/>
+          <p:cNvSpPr/>
+          <p:nvPr/>
+        </p:nvSpPr>
+        <p:spPr>
+          <a:xfrm>
+            <a:off x="658368" y="457200"/>
+            <a:ext cx="8229600" cy="320040"/>
+          </a:xfrm>
+          <a:prstGeom prst="rect">
+            <a:avLst/>
+          </a:prstGeom>
+          <a:noFill/>
+          <a:ln/>
+        </p:spPr>
+        <p:txBody>
+          <a:bodyPr wrap="square" lIns="0" tIns="0" rIns="0" bIns="0" rtlCol="0" anchor="ctr"/>
+          <a:lstStyle/>
+          <a:p>
+            <a:pPr algn="l" indent="0" marL="0">
+              <a:buNone/>
+            </a:pPr>
+            <a:r>
+              <a:rPr lang="en-US" sz="1250" b="1" spc="300" kern="0" dirty="0">
+                <a:solidFill>
+                  <a:srgbClr val="37A278"/>
+                </a:solidFill>
+                <a:latin typeface="Calibri" pitchFamily="34" charset="0"/>
+                <a:ea typeface="Calibri" pitchFamily="34" charset="-122"/>
+                <a:cs typeface="Calibri" pitchFamily="34" charset="-120"/>
+              </a:rPr>
+              <a:t>THE VOLUME PLAY</a:t>
+            </a:r>
+            <a:endParaRPr lang="en-US" sz="1250" dirty="0"/>
+          </a:p>
+        </p:txBody>
+      </p:sp>
+      <p:sp>
+        <p:nvSpPr>
+          <p:cNvPr id="3" name="Text 1"/>
+          <p:cNvSpPr/>
+          <p:nvPr/>
+        </p:nvSpPr>
+        <p:spPr>
+          <a:xfrm>
+            <a:off x="658368" y="841248"/>
+            <a:ext cx="10872216" cy="1051560"/>
+          </a:xfrm>
+          <a:prstGeom prst="rect">
+            <a:avLst/>
+          </a:prstGeom>
+          <a:noFill/>
+          <a:ln/>
+        </p:spPr>
+        <p:txBody>
+          <a:bodyPr wrap="square" lIns="0" tIns="0" rIns="0" bIns="0" rtlCol="0" anchor="ctr"/>
+          <a:lstStyle/>
+          <a:p>
+            <a:pPr algn="l" indent="0" marL="0">
+              <a:lnSpc>
+                <a:spcPct val="100000"/>
+              </a:lnSpc>
+              <a:buNone/>
+            </a:pPr>
+            <a:r>
+              <a:rPr lang="en-US" sz="3400" b="1" dirty="0">
+                <a:solidFill>
+                  <a:srgbClr val="123024"/>
+                </a:solidFill>
+                <a:latin typeface="Calibri" pitchFamily="34" charset="0"/>
+                <a:ea typeface="Calibri" pitchFamily="34" charset="-122"/>
+                <a:cs typeface="Calibri" pitchFamily="34" charset="-120"/>
+              </a:rPr>
+              <a:t>One text secures a year of supply.</a:t>
+            </a:r>
+            <a:endParaRPr lang="en-US" sz="3400" dirty="0"/>
+          </a:p>
+        </p:txBody>
+      </p:sp>
+      <p:sp>
+        <p:nvSpPr>
+          <p:cNvPr id="4" name="Text 2"/>
+          <p:cNvSpPr/>
+          <p:nvPr/>
+        </p:nvSpPr>
+        <p:spPr>
+          <a:xfrm>
+            <a:off x="658368" y="1828800"/>
+            <a:ext cx="10607040" cy="640080"/>
+          </a:xfrm>
+          <a:prstGeom prst="rect">
+            <a:avLst/>
+          </a:prstGeom>
+          <a:noFill/>
+          <a:ln/>
+        </p:spPr>
+        <p:txBody>
+          <a:bodyPr wrap="square" lIns="0" tIns="0" rIns="0" bIns="0" rtlCol="0" anchor="ctr"/>
+          <a:lstStyle/>
+          <a:p>
+            <a:pPr indent="0" marL="0">
+              <a:lnSpc>
+                <a:spcPct val="115000"/>
+              </a:lnSpc>
+              <a:buNone/>
+            </a:pPr>
+            <a:r>
+              <a:rPr lang="en-US" sz="1600" dirty="0">
+                <a:solidFill>
+                  <a:srgbClr val="12201A"/>
+                </a:solidFill>
+                <a:latin typeface="Calibri" pitchFamily="34" charset="0"/>
+                <a:ea typeface="Calibri" pitchFamily="34" charset="-122"/>
+                <a:cs typeface="Calibri" pitchFamily="34" charset="-120"/>
+              </a:rPr>
+              <a:t>The same rails let a big buyer lock in a whole season, direct from the farms — no broker, no procurement team, just a message. This is where the real volume lives.</a:t>
+            </a:r>
+            <a:endParaRPr lang="en-US" sz="1600" dirty="0"/>
+          </a:p>
+        </p:txBody>
+      </p:sp>
+      <p:sp>
+        <p:nvSpPr>
+          <p:cNvPr id="5" name="Shape 3"/>
+          <p:cNvSpPr/>
+          <p:nvPr/>
+        </p:nvSpPr>
+        <p:spPr>
+          <a:xfrm>
+            <a:off x="658368" y="2743200"/>
+            <a:ext cx="3383280" cy="3017520"/>
+          </a:xfrm>
+          <a:prstGeom prst="roundRect">
+            <a:avLst>
+              <a:gd name="adj" fmla="val 4242"/>
+            </a:avLst>
+          </a:prstGeom>
+          <a:solidFill>
+            <a:srgbClr val="FFFFFF"/>
+          </a:solidFill>
+          <a:ln/>
+          <a:effectLst>
+            <a:outerShdw sx="100000" sy="100000" kx="0" ky="0" algn="bl" rotWithShape="0" blurRad="127000" dist="38100" dir="5400000">
+              <a:srgbClr val="1B3A2E">
+                <a:alpha val="16000"/>
+              </a:srgbClr>
+            </a:outerShdw>
+          </a:effectLst>
+        </p:spPr>
+        <p:txBody>
+          <a:bodyPr/>
+          <a:p/>
+        </p:txBody>
+      </p:sp>
+      <p:sp>
+        <p:nvSpPr>
+          <p:cNvPr id="6" name="Shape 4"/>
+          <p:cNvSpPr/>
+          <p:nvPr/>
+        </p:nvSpPr>
+        <p:spPr>
+          <a:xfrm>
+            <a:off x="978408" y="3090672"/>
+            <a:ext cx="777240" cy="777240"/>
+          </a:xfrm>
+          <a:prstGeom prst="ellipse">
+            <a:avLst/>
+          </a:prstGeom>
+          <a:solidFill>
+            <a:srgbClr val="2E8564"/>
+          </a:solidFill>
+          <a:ln/>
+        </p:spPr>
+        <p:txBody>
+          <a:bodyPr/>
+          <a:p/>
+        </p:txBody>
+      </p:sp>
+      <p:sp>
+        <p:nvSpPr>
+          <p:cNvPr id="7" name="Text 5"/>
+          <p:cNvSpPr/>
+          <p:nvPr/>
+        </p:nvSpPr>
+        <p:spPr>
+          <a:xfrm>
+            <a:off x="978408" y="3090672"/>
+            <a:ext cx="777240" cy="777240"/>
+          </a:xfrm>
+          <a:prstGeom prst="rect">
+            <a:avLst/>
+          </a:prstGeom>
+          <a:noFill/>
+          <a:ln/>
+        </p:spPr>
+        <p:txBody>
+          <a:bodyPr wrap="square" lIns="0" tIns="0" rIns="0" bIns="0" rtlCol="0" anchor="ctr"/>
+          <a:lstStyle/>
+          <a:p>
+            <a:pPr algn="ctr" indent="0" marL="0">
+              <a:buNone/>
+            </a:pPr>
+            <a:r>
+              <a:rPr lang="en-US" sz="3000" b="1" dirty="0">
+                <a:solidFill>
+                  <a:srgbClr val="FFFFFF"/>
+                </a:solidFill>
+                <a:latin typeface="Calibri" pitchFamily="34" charset="0"/>
+                <a:ea typeface="Calibri" pitchFamily="34" charset="-122"/>
+                <a:cs typeface="Calibri" pitchFamily="34" charset="-120"/>
+              </a:rPr>
+              <a:t>1</a:t>
+            </a:r>
+            <a:endParaRPr lang="en-US" sz="3000" dirty="0"/>
+          </a:p>
+        </p:txBody>
+      </p:sp>
+      <p:sp>
+        <p:nvSpPr>
+          <p:cNvPr id="8" name="Text 6"/>
+          <p:cNvSpPr/>
+          <p:nvPr/>
+        </p:nvSpPr>
+        <p:spPr>
+          <a:xfrm>
+            <a:off x="1892808" y="3154680"/>
+            <a:ext cx="1920240" cy="320040"/>
+          </a:xfrm>
+          <a:prstGeom prst="rect">
+            <a:avLst/>
+          </a:prstGeom>
+          <a:noFill/>
+          <a:ln/>
+        </p:spPr>
+        <p:txBody>
+          <a:bodyPr wrap="square" lIns="0" tIns="0" rIns="0" bIns="0" rtlCol="0" anchor="ctr"/>
+          <a:lstStyle/>
+          <a:p>
+            <a:pPr indent="0" marL="0">
+              <a:buNone/>
+            </a:pPr>
+            <a:r>
+              <a:rPr lang="en-US" sz="1100" b="1" spc="100" kern="0" dirty="0">
+                <a:solidFill>
+                  <a:srgbClr val="68786F"/>
+                </a:solidFill>
+                <a:latin typeface="Calibri" pitchFamily="34" charset="0"/>
+                <a:ea typeface="Calibri" pitchFamily="34" charset="-122"/>
+                <a:cs typeface="Calibri" pitchFamily="34" charset="-120"/>
+              </a:rPr>
+              <a:t>The ask</a:t>
+            </a:r>
+            <a:endParaRPr lang="en-US" sz="1100" dirty="0"/>
+          </a:p>
+        </p:txBody>
+      </p:sp>
+      <p:sp>
+        <p:nvSpPr>
+          <p:cNvPr id="9" name="Text 7"/>
+          <p:cNvSpPr/>
+          <p:nvPr/>
+        </p:nvSpPr>
+        <p:spPr>
+          <a:xfrm>
+            <a:off x="1892808" y="3429000"/>
+            <a:ext cx="1920240" cy="457200"/>
+          </a:xfrm>
+          <a:prstGeom prst="rect">
+            <a:avLst/>
+          </a:prstGeom>
+          <a:noFill/>
+          <a:ln/>
+        </p:spPr>
+        <p:txBody>
+          <a:bodyPr wrap="square" lIns="0" tIns="0" rIns="0" bIns="0" rtlCol="0" anchor="ctr"/>
+          <a:lstStyle/>
+          <a:p>
+            <a:pPr indent="0" marL="0">
+              <a:buNone/>
+            </a:pPr>
+            <a:r>
+              <a:rPr lang="en-US" sz="1550" b="1" dirty="0">
+                <a:solidFill>
+                  <a:srgbClr val="123024"/>
+                </a:solidFill>
+                <a:latin typeface="Calibri" pitchFamily="34" charset="0"/>
+                <a:ea typeface="Calibri" pitchFamily="34" charset="-122"/>
+                <a:cs typeface="Calibri" pitchFamily="34" charset="-120"/>
+              </a:rPr>
+              <a:t>By a single text</a:t>
+            </a:r>
+            <a:endParaRPr lang="en-US" sz="1550" dirty="0"/>
+          </a:p>
+        </p:txBody>
+      </p:sp>
+      <p:sp>
+        <p:nvSpPr>
+          <p:cNvPr id="10" name="Text 8"/>
+          <p:cNvSpPr/>
+          <p:nvPr/>
+        </p:nvSpPr>
+        <p:spPr>
+          <a:xfrm>
+            <a:off x="978408" y="4251960"/>
+            <a:ext cx="2743200" cy="1280160"/>
+          </a:xfrm>
+          <a:prstGeom prst="rect">
+            <a:avLst/>
+          </a:prstGeom>
+          <a:noFill/>
+          <a:ln/>
+        </p:spPr>
+        <p:txBody>
+          <a:bodyPr wrap="square" lIns="0" tIns="0" rIns="0" bIns="0" rtlCol="0" anchor="ctr"/>
+          <a:lstStyle/>
+          <a:p>
+            <a:pPr indent="0" marL="0">
+              <a:lnSpc>
+                <a:spcPct val="118000"/>
+              </a:lnSpc>
+              <a:buNone/>
+            </a:pPr>
+            <a:r>
+              <a:rPr lang="en-US" sz="1280" dirty="0">
+                <a:solidFill>
+                  <a:srgbClr val="68786F"/>
+                </a:solidFill>
+                <a:latin typeface="Calibri" pitchFamily="34" charset="0"/>
+                <a:ea typeface="Calibri" pitchFamily="34" charset="-122"/>
+                <a:cs typeface="Calibri" pitchFamily="34" charset="-120"/>
+              </a:rPr>
+              <a:t>“Agripals, secure 20 tons of sun-dried tomatoes for the year.” The AI splits it across the farms that can actually grow it, at the price that works.</a:t>
+            </a:r>
+            <a:endParaRPr lang="en-US" sz="1280" dirty="0"/>
+          </a:p>
+        </p:txBody>
+      </p:sp>
+      <p:sp>
+        <p:nvSpPr>
+          <p:cNvPr id="11" name="Shape 9"/>
+          <p:cNvSpPr/>
+          <p:nvPr/>
+        </p:nvSpPr>
+        <p:spPr>
+          <a:xfrm>
+            <a:off x="4334256" y="2743200"/>
+            <a:ext cx="3383280" cy="3017520"/>
+          </a:xfrm>
+          <a:prstGeom prst="roundRect">
+            <a:avLst>
+              <a:gd name="adj" fmla="val 4242"/>
+            </a:avLst>
+          </a:prstGeom>
+          <a:solidFill>
+            <a:srgbClr val="FFFFFF"/>
+          </a:solidFill>
+          <a:ln/>
+          <a:effectLst>
+            <a:outerShdw sx="100000" sy="100000" kx="0" ky="0" algn="bl" rotWithShape="0" blurRad="127000" dist="38100" dir="5400000">
+              <a:srgbClr val="1B3A2E">
+                <a:alpha val="16000"/>
+              </a:srgbClr>
+            </a:outerShdw>
+          </a:effectLst>
+        </p:spPr>
+        <p:txBody>
+          <a:bodyPr/>
+          <a:p/>
+        </p:txBody>
+      </p:sp>
+      <p:sp>
+        <p:nvSpPr>
+          <p:cNvPr id="12" name="Shape 10"/>
+          <p:cNvSpPr/>
+          <p:nvPr/>
+        </p:nvSpPr>
+        <p:spPr>
+          <a:xfrm>
+            <a:off x="4654296" y="3090672"/>
+            <a:ext cx="777240" cy="777240"/>
+          </a:xfrm>
+          <a:prstGeom prst="ellipse">
+            <a:avLst/>
+          </a:prstGeom>
+          <a:solidFill>
+            <a:srgbClr val="37A278"/>
+          </a:solidFill>
+          <a:ln/>
+        </p:spPr>
+        <p:txBody>
+          <a:bodyPr/>
+          <a:p/>
+        </p:txBody>
+      </p:sp>
+      <p:sp>
+        <p:nvSpPr>
+          <p:cNvPr id="13" name="Text 11"/>
+          <p:cNvSpPr/>
+          <p:nvPr/>
+        </p:nvSpPr>
+        <p:spPr>
+          <a:xfrm>
+            <a:off x="4654296" y="3090672"/>
+            <a:ext cx="777240" cy="777240"/>
+          </a:xfrm>
+          <a:prstGeom prst="rect">
+            <a:avLst/>
+          </a:prstGeom>
+          <a:noFill/>
+          <a:ln/>
+        </p:spPr>
+        <p:txBody>
+          <a:bodyPr wrap="square" lIns="0" tIns="0" rIns="0" bIns="0" rtlCol="0" anchor="ctr"/>
+          <a:lstStyle/>
+          <a:p>
+            <a:pPr algn="ctr" indent="0" marL="0">
+              <a:buNone/>
+            </a:pPr>
+            <a:r>
+              <a:rPr lang="en-US" sz="3000" b="1" dirty="0">
+                <a:solidFill>
+                  <a:srgbClr val="FFFFFF"/>
+                </a:solidFill>
+                <a:latin typeface="Calibri" pitchFamily="34" charset="0"/>
+                <a:ea typeface="Calibri" pitchFamily="34" charset="-122"/>
+                <a:cs typeface="Calibri" pitchFamily="34" charset="-120"/>
+              </a:rPr>
+              <a:t>2</a:t>
+            </a:r>
+            <a:endParaRPr lang="en-US" sz="3000" dirty="0"/>
+          </a:p>
+        </p:txBody>
+      </p:sp>
+      <p:sp>
+        <p:nvSpPr>
+          <p:cNvPr id="14" name="Text 12"/>
+          <p:cNvSpPr/>
+          <p:nvPr/>
+        </p:nvSpPr>
+        <p:spPr>
+          <a:xfrm>
+            <a:off x="5568696" y="3154680"/>
+            <a:ext cx="1920240" cy="320040"/>
+          </a:xfrm>
+          <a:prstGeom prst="rect">
+            <a:avLst/>
+          </a:prstGeom>
+          <a:noFill/>
+          <a:ln/>
+        </p:spPr>
+        <p:txBody>
+          <a:bodyPr wrap="square" lIns="0" tIns="0" rIns="0" bIns="0" rtlCol="0" anchor="ctr"/>
+          <a:lstStyle/>
+          <a:p>
+            <a:pPr indent="0" marL="0">
+              <a:buNone/>
+            </a:pPr>
+            <a:r>
+              <a:rPr lang="en-US" sz="1100" b="1" spc="100" kern="0" dirty="0">
+                <a:solidFill>
+                  <a:srgbClr val="68786F"/>
+                </a:solidFill>
+                <a:latin typeface="Calibri" pitchFamily="34" charset="0"/>
+                <a:ea typeface="Calibri" pitchFamily="34" charset="-122"/>
+                <a:cs typeface="Calibri" pitchFamily="34" charset="-120"/>
+              </a:rPr>
+              <a:t>The hard part, solved</a:t>
+            </a:r>
+            <a:endParaRPr lang="en-US" sz="1100" dirty="0"/>
+          </a:p>
+        </p:txBody>
+      </p:sp>
+      <p:sp>
+        <p:nvSpPr>
+          <p:cNvPr id="15" name="Text 13"/>
+          <p:cNvSpPr/>
+          <p:nvPr/>
+        </p:nvSpPr>
+        <p:spPr>
+          <a:xfrm>
+            <a:off x="5568696" y="3429000"/>
+            <a:ext cx="1920240" cy="457200"/>
+          </a:xfrm>
+          <a:prstGeom prst="rect">
+            <a:avLst/>
+          </a:prstGeom>
+          <a:noFill/>
+          <a:ln/>
+        </p:spPr>
+        <p:txBody>
+          <a:bodyPr wrap="square" lIns="0" tIns="0" rIns="0" bIns="0" rtlCol="0" anchor="ctr"/>
+          <a:lstStyle/>
+          <a:p>
+            <a:pPr indent="0" marL="0">
+              <a:buNone/>
+            </a:pPr>
+            <a:r>
+              <a:rPr lang="en-US" sz="1550" b="1" dirty="0">
+                <a:solidFill>
+                  <a:srgbClr val="123024"/>
+                </a:solidFill>
+                <a:latin typeface="Calibri" pitchFamily="34" charset="0"/>
+                <a:ea typeface="Calibri" pitchFamily="34" charset="-122"/>
+                <a:cs typeface="Calibri" pitchFamily="34" charset="-120"/>
+              </a:rPr>
+              <a:t>Many farms, coordinated</a:t>
+            </a:r>
+            <a:endParaRPr lang="en-US" sz="1550" dirty="0"/>
+          </a:p>
+        </p:txBody>
+      </p:sp>
+      <p:sp>
+        <p:nvSpPr>
+          <p:cNvPr id="16" name="Text 14"/>
+          <p:cNvSpPr/>
+          <p:nvPr/>
+        </p:nvSpPr>
+        <p:spPr>
+          <a:xfrm>
+            <a:off x="4654296" y="4251960"/>
+            <a:ext cx="2743200" cy="1280160"/>
+          </a:xfrm>
+          <a:prstGeom prst="rect">
+            <a:avLst/>
+          </a:prstGeom>
+          <a:noFill/>
+          <a:ln/>
+        </p:spPr>
+        <p:txBody>
+          <a:bodyPr wrap="square" lIns="0" tIns="0" rIns="0" bIns="0" rtlCol="0" anchor="ctr"/>
+          <a:lstStyle/>
+          <a:p>
+            <a:pPr indent="0" marL="0">
+              <a:lnSpc>
+                <a:spcPct val="118000"/>
+              </a:lnSpc>
+              <a:buNone/>
+            </a:pPr>
+            <a:r>
+              <a:rPr lang="en-US" sz="1280" dirty="0">
+                <a:solidFill>
+                  <a:srgbClr val="68786F"/>
+                </a:solidFill>
+                <a:latin typeface="Calibri" pitchFamily="34" charset="0"/>
+                <a:ea typeface="Calibri" pitchFamily="34" charset="-122"/>
+                <a:cs typeface="Calibri" pitchFamily="34" charset="-120"/>
+              </a:rPr>
+              <a:t>Chains like Chipotle already want direct, multi-year farmer contracts — but wrangling 20+ small farms is the barrier. AI handles sourcing, pricing and the paperwork.</a:t>
+            </a:r>
+            <a:endParaRPr lang="en-US" sz="1280" dirty="0"/>
+          </a:p>
+        </p:txBody>
+      </p:sp>
+      <p:sp>
+        <p:nvSpPr>
+          <p:cNvPr id="17" name="Shape 15"/>
+          <p:cNvSpPr/>
+          <p:nvPr/>
+        </p:nvSpPr>
+        <p:spPr>
+          <a:xfrm>
+            <a:off x="8010144" y="2743200"/>
+            <a:ext cx="3383280" cy="3017520"/>
+          </a:xfrm>
+          <a:prstGeom prst="roundRect">
+            <a:avLst>
+              <a:gd name="adj" fmla="val 4242"/>
+            </a:avLst>
+          </a:prstGeom>
+          <a:solidFill>
+            <a:srgbClr val="FFFFFF"/>
+          </a:solidFill>
+          <a:ln/>
+          <a:effectLst>
+            <a:outerShdw sx="100000" sy="100000" kx="0" ky="0" algn="bl" rotWithShape="0" blurRad="127000" dist="38100" dir="5400000">
+              <a:srgbClr val="1B3A2E">
+                <a:alpha val="16000"/>
+              </a:srgbClr>
+            </a:outerShdw>
+          </a:effectLst>
+        </p:spPr>
+        <p:txBody>
+          <a:bodyPr/>
+          <a:p/>
+        </p:txBody>
+      </p:sp>
+      <p:sp>
+        <p:nvSpPr>
+          <p:cNvPr id="18" name="Shape 16"/>
+          <p:cNvSpPr/>
+          <p:nvPr/>
+        </p:nvSpPr>
+        <p:spPr>
+          <a:xfrm>
+            <a:off x="8330184" y="3090672"/>
+            <a:ext cx="777240" cy="777240"/>
+          </a:xfrm>
+          <a:prstGeom prst="ellipse">
+            <a:avLst/>
+          </a:prstGeom>
+          <a:solidFill>
+            <a:srgbClr val="4CC499"/>
+          </a:solidFill>
+          <a:ln/>
+        </p:spPr>
+        <p:txBody>
+          <a:bodyPr/>
+          <a:p/>
+        </p:txBody>
+      </p:sp>
+      <p:sp>
+        <p:nvSpPr>
+          <p:cNvPr id="19" name="Text 17"/>
+          <p:cNvSpPr/>
+          <p:nvPr/>
+        </p:nvSpPr>
+        <p:spPr>
+          <a:xfrm>
+            <a:off x="8330184" y="3090672"/>
+            <a:ext cx="777240" cy="777240"/>
+          </a:xfrm>
+          <a:prstGeom prst="rect">
+            <a:avLst/>
+          </a:prstGeom>
+          <a:noFill/>
+          <a:ln/>
+        </p:spPr>
+        <p:txBody>
+          <a:bodyPr wrap="square" lIns="0" tIns="0" rIns="0" bIns="0" rtlCol="0" anchor="ctr"/>
+          <a:lstStyle/>
+          <a:p>
+            <a:pPr algn="ctr" indent="0" marL="0">
+              <a:buNone/>
+            </a:pPr>
+            <a:r>
+              <a:rPr lang="en-US" sz="3000" b="1" dirty="0">
+                <a:solidFill>
+                  <a:srgbClr val="FFFFFF"/>
+                </a:solidFill>
+                <a:latin typeface="Calibri" pitchFamily="34" charset="0"/>
+                <a:ea typeface="Calibri" pitchFamily="34" charset="-122"/>
+                <a:cs typeface="Calibri" pitchFamily="34" charset="-120"/>
+              </a:rPr>
+              <a:t>3</a:t>
+            </a:r>
+            <a:endParaRPr lang="en-US" sz="3000" dirty="0"/>
+          </a:p>
+        </p:txBody>
+      </p:sp>
+      <p:sp>
+        <p:nvSpPr>
+          <p:cNvPr id="20" name="Text 18"/>
+          <p:cNvSpPr/>
+          <p:nvPr/>
+        </p:nvSpPr>
+        <p:spPr>
+          <a:xfrm>
+            <a:off x="9244584" y="3154680"/>
+            <a:ext cx="1920240" cy="320040"/>
+          </a:xfrm>
+          <a:prstGeom prst="rect">
+            <a:avLst/>
+          </a:prstGeom>
+          <a:noFill/>
+          <a:ln/>
+        </p:spPr>
+        <p:txBody>
+          <a:bodyPr wrap="square" lIns="0" tIns="0" rIns="0" bIns="0" rtlCol="0" anchor="ctr"/>
+          <a:lstStyle/>
+          <a:p>
+            <a:pPr indent="0" marL="0">
+              <a:buNone/>
+            </a:pPr>
+            <a:r>
+              <a:rPr lang="en-US" sz="1100" b="1" spc="100" kern="0" dirty="0">
+                <a:solidFill>
+                  <a:srgbClr val="68786F"/>
+                </a:solidFill>
+                <a:latin typeface="Calibri" pitchFamily="34" charset="0"/>
+                <a:ea typeface="Calibri" pitchFamily="34" charset="-122"/>
+                <a:cs typeface="Calibri" pitchFamily="34" charset="-120"/>
+              </a:rPr>
+              <a:t>The market</a:t>
+            </a:r>
+            <a:endParaRPr lang="en-US" sz="1100" dirty="0"/>
+          </a:p>
+        </p:txBody>
+      </p:sp>
+      <p:sp>
+        <p:nvSpPr>
+          <p:cNvPr id="21" name="Text 19"/>
+          <p:cNvSpPr/>
+          <p:nvPr/>
+        </p:nvSpPr>
+        <p:spPr>
+          <a:xfrm>
+            <a:off x="9244584" y="3429000"/>
+            <a:ext cx="1920240" cy="457200"/>
+          </a:xfrm>
+          <a:prstGeom prst="rect">
+            <a:avLst/>
+          </a:prstGeom>
+          <a:noFill/>
+          <a:ln/>
+        </p:spPr>
+        <p:txBody>
+          <a:bodyPr wrap="square" lIns="0" tIns="0" rIns="0" bIns="0" rtlCol="0" anchor="ctr"/>
+          <a:lstStyle/>
+          <a:p>
+            <a:pPr indent="0" marL="0">
+              <a:buNone/>
+            </a:pPr>
+            <a:r>
+              <a:rPr lang="en-US" sz="1550" b="1" dirty="0">
+                <a:solidFill>
+                  <a:srgbClr val="123024"/>
+                </a:solidFill>
+                <a:latin typeface="Calibri" pitchFamily="34" charset="0"/>
+                <a:ea typeface="Calibri" pitchFamily="34" charset="-122"/>
+                <a:cs typeface="Calibri" pitchFamily="34" charset="-120"/>
+              </a:rPr>
+              <a:t>A $62B layer to own</a:t>
+            </a:r>
+            <a:endParaRPr lang="en-US" sz="1550" dirty="0"/>
+          </a:p>
+        </p:txBody>
+      </p:sp>
+      <p:sp>
+        <p:nvSpPr>
+          <p:cNvPr id="22" name="Text 20"/>
+          <p:cNvSpPr/>
+          <p:nvPr/>
+        </p:nvSpPr>
+        <p:spPr>
+          <a:xfrm>
+            <a:off x="8330184" y="4251960"/>
+            <a:ext cx="2743200" cy="1280160"/>
+          </a:xfrm>
+          <a:prstGeom prst="rect">
+            <a:avLst/>
+          </a:prstGeom>
+          <a:noFill/>
+          <a:ln/>
+        </p:spPr>
+        <p:txBody>
+          <a:bodyPr wrap="square" lIns="0" tIns="0" rIns="0" bIns="0" rtlCol="0" anchor="ctr"/>
+          <a:lstStyle/>
+          <a:p>
+            <a:pPr indent="0" marL="0">
+              <a:lnSpc>
+                <a:spcPct val="118000"/>
+              </a:lnSpc>
+              <a:buNone/>
+            </a:pPr>
+            <a:r>
+              <a:rPr lang="en-US" sz="1280" dirty="0">
+                <a:solidFill>
+                  <a:srgbClr val="68786F"/>
+                </a:solidFill>
+                <a:latin typeface="Calibri" pitchFamily="34" charset="0"/>
+                <a:ea typeface="Calibri" pitchFamily="34" charset="-122"/>
+                <a:cs typeface="Calibri" pitchFamily="34" charset="-120"/>
+              </a:rPr>
+              <a:t>Contract farming is a $62B global market. Agripals becomes the layer where big buyers and small farms meet — and we take a cut of every ton.</a:t>
+            </a:r>
+            <a:endParaRPr lang="en-US" sz="1280" dirty="0"/>
+          </a:p>
+        </p:txBody>
+      </p:sp>
+      <p:sp>
+        <p:nvSpPr>
+          <p:cNvPr id="23" name="Text 21"/>
+          <p:cNvSpPr/>
+          <p:nvPr/>
+        </p:nvSpPr>
+        <p:spPr>
+          <a:xfrm>
+            <a:off x="11183112" y="6355080"/>
+            <a:ext cx="548640" cy="274320"/>
+          </a:xfrm>
+          <a:prstGeom prst="rect">
+            <a:avLst/>
+          </a:prstGeom>
+          <a:noFill/>
+          <a:ln/>
+        </p:spPr>
+        <p:txBody>
+          <a:bodyPr wrap="square" lIns="0" tIns="0" rIns="0" bIns="0" rtlCol="0" anchor="ctr"/>
+          <a:lstStyle/>
+          <a:p>
+            <a:pPr algn="r" indent="0" marL="0">
+              <a:buNone/>
+            </a:pPr>
+            <a:r>
+              <a:rPr lang="en-US" sz="1000" dirty="0">
+                <a:solidFill>
+                  <a:srgbClr val="68786F"/>
+                </a:solidFill>
+                <a:latin typeface="Calibri" pitchFamily="34" charset="0"/>
+                <a:ea typeface="Calibri" pitchFamily="34" charset="-122"/>
+                <a:cs typeface="Calibri" pitchFamily="34" charset="-120"/>
+              </a:rPr>
+              <a:t>20</a:t>
+            </a:r>
+            <a:endParaRPr lang="en-US" sz="1000" dirty="0"/>
+          </a:p>
+        </p:txBody>
+      </p:sp>
+      <p:sp>
+        <p:nvSpPr>
+          <p:cNvPr id="24" name="Text 22"/>
+          <p:cNvSpPr/>
+          <p:nvPr/>
+        </p:nvSpPr>
+        <p:spPr>
+          <a:xfrm>
+            <a:off x="658368" y="6355080"/>
+            <a:ext cx="2743200" cy="274320"/>
+          </a:xfrm>
+          <a:prstGeom prst="rect">
+            <a:avLst/>
+          </a:prstGeom>
+          <a:noFill/>
+          <a:ln/>
+        </p:spPr>
+        <p:txBody>
+          <a:bodyPr wrap="square" lIns="0" tIns="0" rIns="0" bIns="0" rtlCol="0" anchor="ctr"/>
+          <a:lstStyle/>
+          <a:p>
+            <a:pPr indent="0" marL="0">
+              <a:buNone/>
+            </a:pPr>
+            <a:r>
+              <a:rPr lang="en-US" sz="1000" b="1" dirty="0">
+                <a:solidFill>
+                  <a:srgbClr val="68786F"/>
+                </a:solidFill>
+                <a:latin typeface="Calibri" pitchFamily="34" charset="0"/>
+                <a:ea typeface="Calibri" pitchFamily="34" charset="-122"/>
+                <a:cs typeface="Calibri" pitchFamily="34" charset="-120"/>
+              </a:rPr>
+              <a:t>Agripals</a:t>
+            </a:r>
+            <a:endParaRPr lang="en-US" sz="1000" dirty="0"/>
+          </a:p>
+        </p:txBody>
+      </p:sp>
+    </p:spTree>
+  </p:cSld>
+  <p:clrMapOvr>
+    <a:masterClrMapping/>
+  </p:clrMapOvr>
+</p:sld>
+</file>
+
+<file path=ppt/slides/slide21.xml><?xml version="1.0" encoding="utf-8"?>
+<p:sld xmlns:a="http://schemas.openxmlformats.org/drawingml/2006/main" xmlns:r="http://schemas.openxmlformats.org/officeDocument/2006/relationships" xmlns:p="http://schemas.openxmlformats.org/presentationml/2006/main">
   <p:cSld name="Slide 14">
     <p:bg>
       <p:bgPr>

</xml_diff>